<commit_message>
2026-08-26 Wed 1440: Add Problem Statement, Research Objectives, and System Block Diagram to MADN Presentation (Ukukhulisa 1.19.21)
</commit_message>
<xml_diff>
--- a/01_Documentation_and_Thesis/MADN_Dynamic_Value_Systems_Presentation.pptx
+++ b/01_Documentation_and_Thesis/MADN_Dynamic_Value_Systems_Presentation.pptx
@@ -14,6 +14,8 @@
     <p:sldId id="262" r:id="rId13"/>
     <p:sldId id="263" r:id="rId14"/>
     <p:sldId id="264" r:id="rId15"/>
+    <p:sldId id="265" r:id="rId16"/>
+    <p:sldId id="266" r:id="rId17"/>
   </p:sldIdLst>
   <p:sldSz cx="12191695" cy="6858000" type="screen4x3"/>
   <p:notesSz cx="6858000" cy="9144000"/>
@@ -3157,8 +3159,8 @@
         </p:nvSpPr>
         <p:spPr>
           <a:xfrm>
-            <a:off x="1463040" y="1463040"/>
-            <a:ext cx="9265615" cy="3931920"/>
+            <a:off x="1463040" y="1371600"/>
+            <a:ext cx="9265615" cy="4114800"/>
           </a:xfrm>
           <a:prstGeom prst="rect">
             <a:avLst/>
@@ -3229,6 +3231,716 @@
             </a:pPr>
             <a:r>
               <a:t>🚀 Zero Cloud Subscriptions • 🔒 AES-256-GCM Vault • ⚡ Wi-Fi 7 Sub-Millisecond Mesh • 🌾 Precision Agri &amp; Touch POS</a:t>
+            </a:r>
+          </a:p>
+        </p:txBody>
+      </p:sp>
+    </p:spTree>
+  </p:cSld>
+  <p:clrMapOvr>
+    <a:masterClrMapping/>
+  </p:clrMapOvr>
+</p:sld>
+</file>
+
+<file path=ppt/slides/slide10.xml><?xml version="1.0" encoding="utf-8"?>
+<p:sld xmlns:a="http://schemas.openxmlformats.org/drawingml/2006/main" xmlns:p="http://schemas.openxmlformats.org/presentationml/2006/main" xmlns:r="http://schemas.openxmlformats.org/officeDocument/2006/relationships">
+  <p:cSld>
+    <p:bg>
+      <p:bgPr>
+        <a:solidFill>
+          <a:srgbClr val="06080D"/>
+        </a:solidFill>
+        <a:effectLst/>
+      </p:bgPr>
+    </p:bg>
+    <p:spTree>
+      <p:nvGrpSpPr>
+        <p:cNvPr id="1" name=""/>
+        <p:cNvGrpSpPr/>
+        <p:nvPr/>
+      </p:nvGrpSpPr>
+      <p:grpSpPr/>
+      <p:sp>
+        <p:nvSpPr>
+          <p:cNvPr id="2" name="TextBox 1"/>
+          <p:cNvSpPr txBox="1"/>
+          <p:nvPr/>
+        </p:nvSpPr>
+        <p:spPr>
+          <a:xfrm>
+            <a:off x="731520" y="365760"/>
+            <a:ext cx="10698480" cy="320040"/>
+          </a:xfrm>
+          <a:prstGeom prst="rect">
+            <a:avLst/>
+          </a:prstGeom>
+          <a:noFill/>
+        </p:spPr>
+        <p:txBody>
+          <a:bodyPr wrap="square">
+            <a:spAutoFit/>
+          </a:bodyPr>
+          <a:lstStyle/>
+          <a:p>
+            <a:pPr>
+              <a:defRPr sz="1100" b="1">
+                <a:solidFill>
+                  <a:srgbClr val="00E5FF"/>
+                </a:solidFill>
+              </a:defRPr>
+            </a:pPr>
+            <a:r>
+              <a:t>MODULAR ADAPTIVE DATA NODE (MADN) • DYNAMIC VALUE SYSTEMS</a:t>
+            </a:r>
+          </a:p>
+        </p:txBody>
+      </p:sp>
+      <p:sp>
+        <p:nvSpPr>
+          <p:cNvPr id="3" name="TextBox 2"/>
+          <p:cNvSpPr txBox="1"/>
+          <p:nvPr/>
+        </p:nvSpPr>
+        <p:spPr>
+          <a:xfrm>
+            <a:off x="731520" y="685800"/>
+            <a:ext cx="10698480" cy="640080"/>
+          </a:xfrm>
+          <a:prstGeom prst="rect">
+            <a:avLst/>
+          </a:prstGeom>
+          <a:noFill/>
+        </p:spPr>
+        <p:txBody>
+          <a:bodyPr wrap="square">
+            <a:spAutoFit/>
+          </a:bodyPr>
+          <a:lstStyle/>
+          <a:p>
+            <a:pPr>
+              <a:defRPr sz="2300" b="1">
+                <a:solidFill>
+                  <a:srgbClr val="FFFFFF"/>
+                </a:solidFill>
+              </a:defRPr>
+            </a:pPr>
+            <a:r>
+              <a:t>The Exponential Trajectory: The Next Decade of Local Compute</a:t>
+            </a:r>
+          </a:p>
+        </p:txBody>
+      </p:sp>
+      <p:sp>
+        <p:nvSpPr>
+          <p:cNvPr id="4" name="Rounded Rectangle 3"/>
+          <p:cNvSpPr/>
+          <p:nvPr/>
+        </p:nvSpPr>
+        <p:spPr>
+          <a:xfrm>
+            <a:off x="731520" y="1463040"/>
+            <a:ext cx="3328416" cy="4663440"/>
+          </a:xfrm>
+          <a:prstGeom prst="roundRect">
+            <a:avLst/>
+          </a:prstGeom>
+          <a:solidFill>
+            <a:srgbClr val="111827"/>
+          </a:solidFill>
+          <a:ln w="19050">
+            <a:solidFill>
+              <a:srgbClr val="00E5FF"/>
+            </a:solidFill>
+          </a:ln>
+        </p:spPr>
+        <p:style>
+          <a:lnRef idx="1">
+            <a:schemeClr val="accent1"/>
+          </a:lnRef>
+          <a:fillRef idx="3">
+            <a:schemeClr val="accent1"/>
+          </a:fillRef>
+          <a:effectRef idx="2">
+            <a:schemeClr val="accent1"/>
+          </a:effectRef>
+          <a:fontRef idx="minor">
+            <a:schemeClr val="lt1"/>
+          </a:fontRef>
+        </p:style>
+        <p:txBody>
+          <a:bodyPr rtlCol="0" anchor="ctr"/>
+          <a:lstStyle/>
+          <a:p>
+            <a:pPr algn="ctr"/>
+          </a:p>
+        </p:txBody>
+      </p:sp>
+      <p:sp>
+        <p:nvSpPr>
+          <p:cNvPr id="5" name="TextBox 4"/>
+          <p:cNvSpPr txBox="1"/>
+          <p:nvPr/>
+        </p:nvSpPr>
+        <p:spPr>
+          <a:xfrm>
+            <a:off x="914400" y="1645920"/>
+            <a:ext cx="2962656" cy="4297680"/>
+          </a:xfrm>
+          <a:prstGeom prst="rect">
+            <a:avLst/>
+          </a:prstGeom>
+          <a:noFill/>
+        </p:spPr>
+        <p:txBody>
+          <a:bodyPr wrap="square">
+            <a:spAutoFit/>
+          </a:bodyPr>
+          <a:lstStyle/>
+          <a:p>
+            <a:pPr>
+              <a:spcAft>
+                <a:spcPts val="1200"/>
+              </a:spcAft>
+              <a:defRPr sz="1700" b="1">
+                <a:solidFill>
+                  <a:srgbClr val="00E5FF"/>
+                </a:solidFill>
+              </a:defRPr>
+            </a:pPr>
+            <a:r>
+              <a:t>📶 1. Wi-Fi 8 &amp; mmWave Mesh</a:t>
+            </a:r>
+          </a:p>
+          <a:p>
+            <a:pPr>
+              <a:defRPr sz="1200">
+                <a:solidFill>
+                  <a:srgbClr val="94A3B8"/>
+                </a:solidFill>
+              </a:defRPr>
+            </a:pPr>
+            <a:r>
+              <a:t>Next-gen local wireless will exceed 100 Gbps with sub-millisecond deterministic latency.</a:t>
+            </a:r>
+            <a:br/>
+            <a:br/>
+            <a:r>
+              <a:t>• Entire neighborhood economies will sync databases across peer meshes without relying on cellular towers or ISP uplinks.</a:t>
+            </a:r>
+            <a:br/>
+            <a:r>
+              <a:t>• High-density store-to-store data sharing with zero bandwidth costs.</a:t>
+            </a:r>
+          </a:p>
+        </p:txBody>
+      </p:sp>
+      <p:sp>
+        <p:nvSpPr>
+          <p:cNvPr id="6" name="Rounded Rectangle 5"/>
+          <p:cNvSpPr/>
+          <p:nvPr/>
+        </p:nvSpPr>
+        <p:spPr>
+          <a:xfrm>
+            <a:off x="4425696" y="1463040"/>
+            <a:ext cx="3328416" cy="4663440"/>
+          </a:xfrm>
+          <a:prstGeom prst="roundRect">
+            <a:avLst/>
+          </a:prstGeom>
+          <a:solidFill>
+            <a:srgbClr val="111827"/>
+          </a:solidFill>
+          <a:ln w="19050">
+            <a:solidFill>
+              <a:srgbClr val="7C4DFF"/>
+            </a:solidFill>
+          </a:ln>
+        </p:spPr>
+        <p:style>
+          <a:lnRef idx="1">
+            <a:schemeClr val="accent1"/>
+          </a:lnRef>
+          <a:fillRef idx="3">
+            <a:schemeClr val="accent1"/>
+          </a:fillRef>
+          <a:effectRef idx="2">
+            <a:schemeClr val="accent1"/>
+          </a:effectRef>
+          <a:fontRef idx="minor">
+            <a:schemeClr val="lt1"/>
+          </a:fontRef>
+        </p:style>
+        <p:txBody>
+          <a:bodyPr rtlCol="0" anchor="ctr"/>
+          <a:lstStyle/>
+          <a:p>
+            <a:pPr algn="ctr"/>
+          </a:p>
+        </p:txBody>
+      </p:sp>
+      <p:sp>
+        <p:nvSpPr>
+          <p:cNvPr id="7" name="TextBox 6"/>
+          <p:cNvSpPr txBox="1"/>
+          <p:nvPr/>
+        </p:nvSpPr>
+        <p:spPr>
+          <a:xfrm>
+            <a:off x="4608576" y="1645920"/>
+            <a:ext cx="2962656" cy="4297680"/>
+          </a:xfrm>
+          <a:prstGeom prst="rect">
+            <a:avLst/>
+          </a:prstGeom>
+          <a:noFill/>
+        </p:spPr>
+        <p:txBody>
+          <a:bodyPr wrap="square">
+            <a:spAutoFit/>
+          </a:bodyPr>
+          <a:lstStyle/>
+          <a:p>
+            <a:pPr>
+              <a:spcAft>
+                <a:spcPts val="1200"/>
+              </a:spcAft>
+              <a:defRPr sz="1700" b="1">
+                <a:solidFill>
+                  <a:srgbClr val="7C4DFF"/>
+                </a:solidFill>
+              </a:defRPr>
+            </a:pPr>
+            <a:r>
+              <a:t>🧠 2. On-Device NPUs &amp; Edge AI</a:t>
+            </a:r>
+          </a:p>
+          <a:p>
+            <a:pPr>
+              <a:defRPr sz="1200">
+                <a:solidFill>
+                  <a:srgbClr val="94A3B8"/>
+                </a:solidFill>
+              </a:defRPr>
+            </a:pPr>
+            <a:r>
+              <a:t>Neural Processing Units (NPUs) on consumer chips will run quantized LLMs locally at 100+ tokens/sec.</a:t>
+            </a:r>
+            <a:br/>
+            <a:br/>
+            <a:r>
+              <a:t>• MADN nodes will execute autonomous inventory forecasting, predictive crop yield analysis, and automated market negotiation right on the farm or cash register.</a:t>
+            </a:r>
+          </a:p>
+        </p:txBody>
+      </p:sp>
+      <p:sp>
+        <p:nvSpPr>
+          <p:cNvPr id="8" name="Rounded Rectangle 7"/>
+          <p:cNvSpPr/>
+          <p:nvPr/>
+        </p:nvSpPr>
+        <p:spPr>
+          <a:xfrm>
+            <a:off x="8119872" y="1463040"/>
+            <a:ext cx="3328416" cy="4663440"/>
+          </a:xfrm>
+          <a:prstGeom prst="roundRect">
+            <a:avLst/>
+          </a:prstGeom>
+          <a:solidFill>
+            <a:srgbClr val="111827"/>
+          </a:solidFill>
+          <a:ln w="19050">
+            <a:solidFill>
+              <a:srgbClr val="10B981"/>
+            </a:solidFill>
+          </a:ln>
+        </p:spPr>
+        <p:style>
+          <a:lnRef idx="1">
+            <a:schemeClr val="accent1"/>
+          </a:lnRef>
+          <a:fillRef idx="3">
+            <a:schemeClr val="accent1"/>
+          </a:fillRef>
+          <a:effectRef idx="2">
+            <a:schemeClr val="accent1"/>
+          </a:effectRef>
+          <a:fontRef idx="minor">
+            <a:schemeClr val="lt1"/>
+          </a:fontRef>
+        </p:style>
+        <p:txBody>
+          <a:bodyPr rtlCol="0" anchor="ctr"/>
+          <a:lstStyle/>
+          <a:p>
+            <a:pPr algn="ctr"/>
+          </a:p>
+        </p:txBody>
+      </p:sp>
+      <p:sp>
+        <p:nvSpPr>
+          <p:cNvPr id="9" name="TextBox 8"/>
+          <p:cNvSpPr txBox="1"/>
+          <p:nvPr/>
+        </p:nvSpPr>
+        <p:spPr>
+          <a:xfrm>
+            <a:off x="8302752" y="1645920"/>
+            <a:ext cx="2962656" cy="4297680"/>
+          </a:xfrm>
+          <a:prstGeom prst="rect">
+            <a:avLst/>
+          </a:prstGeom>
+          <a:noFill/>
+        </p:spPr>
+        <p:txBody>
+          <a:bodyPr wrap="square">
+            <a:spAutoFit/>
+          </a:bodyPr>
+          <a:lstStyle/>
+          <a:p>
+            <a:pPr>
+              <a:spcAft>
+                <a:spcPts val="1200"/>
+              </a:spcAft>
+              <a:defRPr sz="1700" b="1">
+                <a:solidFill>
+                  <a:srgbClr val="10B981"/>
+                </a:solidFill>
+              </a:defRPr>
+            </a:pPr>
+            <a:r>
+              <a:t>🌍 3. Sovereign Resilient Economies</a:t>
+            </a:r>
+          </a:p>
+          <a:p>
+            <a:pPr>
+              <a:defRPr sz="1200">
+                <a:solidFill>
+                  <a:srgbClr val="94A3B8"/>
+                </a:solidFill>
+              </a:defRPr>
+            </a:pPr>
+            <a:r>
+              <a:t>Decentralization shifts from a theoretical ideal to an undeniable economic advantage.</a:t>
+            </a:r>
+            <a:br/>
+            <a:br/>
+            <a:r>
+              <a:t>• Communities become immune to hyperinflation, platform de-platforming, and subsea cable cuts.</a:t>
+            </a:r>
+            <a:br/>
+            <a:r>
+              <a:t>• Local trade continues seamlessly, privately, and reliably forever.</a:t>
+            </a:r>
+          </a:p>
+        </p:txBody>
+      </p:sp>
+    </p:spTree>
+  </p:cSld>
+  <p:clrMapOvr>
+    <a:masterClrMapping/>
+  </p:clrMapOvr>
+</p:sld>
+</file>
+
+<file path=ppt/slides/slide11.xml><?xml version="1.0" encoding="utf-8"?>
+<p:sld xmlns:a="http://schemas.openxmlformats.org/drawingml/2006/main" xmlns:p="http://schemas.openxmlformats.org/presentationml/2006/main" xmlns:r="http://schemas.openxmlformats.org/officeDocument/2006/relationships">
+  <p:cSld>
+    <p:bg>
+      <p:bgPr>
+        <a:solidFill>
+          <a:srgbClr val="06080D"/>
+        </a:solidFill>
+        <a:effectLst/>
+      </p:bgPr>
+    </p:bg>
+    <p:spTree>
+      <p:nvGrpSpPr>
+        <p:cNvPr id="1" name=""/>
+        <p:cNvGrpSpPr/>
+        <p:nvPr/>
+      </p:nvGrpSpPr>
+      <p:grpSpPr/>
+      <p:sp>
+        <p:nvSpPr>
+          <p:cNvPr id="2" name="TextBox 1"/>
+          <p:cNvSpPr txBox="1"/>
+          <p:nvPr/>
+        </p:nvSpPr>
+        <p:spPr>
+          <a:xfrm>
+            <a:off x="731520" y="365760"/>
+            <a:ext cx="10698480" cy="320040"/>
+          </a:xfrm>
+          <a:prstGeom prst="rect">
+            <a:avLst/>
+          </a:prstGeom>
+          <a:noFill/>
+        </p:spPr>
+        <p:txBody>
+          <a:bodyPr wrap="square">
+            <a:spAutoFit/>
+          </a:bodyPr>
+          <a:lstStyle/>
+          <a:p>
+            <a:pPr>
+              <a:defRPr sz="1100" b="1">
+                <a:solidFill>
+                  <a:srgbClr val="00E5FF"/>
+                </a:solidFill>
+              </a:defRPr>
+            </a:pPr>
+            <a:r>
+              <a:t>MODULAR ADAPTIVE DATA NODE (MADN) • DYNAMIC VALUE SYSTEMS</a:t>
+            </a:r>
+          </a:p>
+        </p:txBody>
+      </p:sp>
+      <p:sp>
+        <p:nvSpPr>
+          <p:cNvPr id="3" name="TextBox 2"/>
+          <p:cNvSpPr txBox="1"/>
+          <p:nvPr/>
+        </p:nvSpPr>
+        <p:spPr>
+          <a:xfrm>
+            <a:off x="731520" y="685800"/>
+            <a:ext cx="10698480" cy="640080"/>
+          </a:xfrm>
+          <a:prstGeom prst="rect">
+            <a:avLst/>
+          </a:prstGeom>
+          <a:noFill/>
+        </p:spPr>
+        <p:txBody>
+          <a:bodyPr wrap="square">
+            <a:spAutoFit/>
+          </a:bodyPr>
+          <a:lstStyle/>
+          <a:p>
+            <a:pPr>
+              <a:defRPr sz="2300" b="1">
+                <a:solidFill>
+                  <a:srgbClr val="FFFFFF"/>
+                </a:solidFill>
+              </a:defRPr>
+            </a:pPr>
+            <a:r>
+              <a:t>Conclusion: The Future of Value Systems is Local and Sovereign</a:t>
+            </a:r>
+          </a:p>
+        </p:txBody>
+      </p:sp>
+      <p:sp>
+        <p:nvSpPr>
+          <p:cNvPr id="4" name="Rounded Rectangle 3"/>
+          <p:cNvSpPr/>
+          <p:nvPr/>
+        </p:nvSpPr>
+        <p:spPr>
+          <a:xfrm>
+            <a:off x="1097280" y="1371600"/>
+            <a:ext cx="9997135" cy="4846320"/>
+          </a:xfrm>
+          <a:prstGeom prst="roundRect">
+            <a:avLst/>
+          </a:prstGeom>
+          <a:solidFill>
+            <a:srgbClr val="111827"/>
+          </a:solidFill>
+          <a:ln w="19050">
+            <a:solidFill>
+              <a:srgbClr val="00E5FF"/>
+            </a:solidFill>
+          </a:ln>
+        </p:spPr>
+        <p:style>
+          <a:lnRef idx="1">
+            <a:schemeClr val="accent1"/>
+          </a:lnRef>
+          <a:fillRef idx="3">
+            <a:schemeClr val="accent1"/>
+          </a:fillRef>
+          <a:effectRef idx="2">
+            <a:schemeClr val="accent1"/>
+          </a:effectRef>
+          <a:fontRef idx="minor">
+            <a:schemeClr val="lt1"/>
+          </a:fontRef>
+        </p:style>
+        <p:txBody>
+          <a:bodyPr rtlCol="0" anchor="ctr"/>
+          <a:lstStyle/>
+          <a:p>
+            <a:pPr algn="ctr"/>
+          </a:p>
+        </p:txBody>
+      </p:sp>
+      <p:sp>
+        <p:nvSpPr>
+          <p:cNvPr id="5" name="TextBox 4"/>
+          <p:cNvSpPr txBox="1"/>
+          <p:nvPr/>
+        </p:nvSpPr>
+        <p:spPr>
+          <a:xfrm>
+            <a:off x="1463040" y="1645920"/>
+            <a:ext cx="9265615" cy="4297680"/>
+          </a:xfrm>
+          <a:prstGeom prst="rect">
+            <a:avLst/>
+          </a:prstGeom>
+          <a:noFill/>
+        </p:spPr>
+        <p:txBody>
+          <a:bodyPr wrap="square">
+            <a:spAutoFit/>
+          </a:bodyPr>
+          <a:lstStyle/>
+          <a:p>
+            <a:pPr>
+              <a:spcAft>
+                <a:spcPts val="1400"/>
+              </a:spcAft>
+              <a:defRPr sz="2000" b="1">
+                <a:solidFill>
+                  <a:srgbClr val="00E5FF"/>
+                </a:solidFill>
+              </a:defRPr>
+            </a:pPr>
+            <a:r>
+              <a:t>🎯 Summary &amp; Technical Milestones</a:t>
+            </a:r>
+          </a:p>
+          <a:p>
+            <a:pPr>
+              <a:spcAft>
+                <a:spcPts val="1000"/>
+              </a:spcAft>
+              <a:defRPr b="1" sz="1300">
+                <a:solidFill>
+                  <a:srgbClr val="FFFFFF"/>
+                </a:solidFill>
+              </a:defRPr>
+            </a:pPr>
+            <a:r>
+              <a:t>✔ Unlocking Idle Edge Assets: </a:t>
+            </a:r>
+            <a:r>
+              <a:rPr b="0">
+                <a:solidFill>
+                  <a:srgbClr val="94A3B8"/>
+                </a:solidFill>
+              </a:rPr>
+              <a:t>Transforming commodity consumer devices into zero-cost, high-performance financial infrastructure.</a:t>
+            </a:r>
+          </a:p>
+          <a:p>
+            <a:pPr>
+              <a:spcAft>
+                <a:spcPts val="1000"/>
+              </a:spcAft>
+              <a:defRPr b="1" sz="1300">
+                <a:solidFill>
+                  <a:srgbClr val="FFFFFF"/>
+                </a:solidFill>
+              </a:defRPr>
+            </a:pPr>
+            <a:r>
+              <a:t>✔ 100% Automated Test Matrix: </a:t>
+            </a:r>
+            <a:r>
+              <a:rPr b="0">
+                <a:solidFill>
+                  <a:srgbClr val="94A3B8"/>
+                </a:solidFill>
+              </a:rPr>
+              <a:t>49 comprehensive unit and integration tests passing with 100% reliability across all security and pricing tiers.</a:t>
+            </a:r>
+          </a:p>
+          <a:p>
+            <a:pPr>
+              <a:spcAft>
+                <a:spcPts val="1000"/>
+              </a:spcAft>
+              <a:defRPr b="1" sz="1300">
+                <a:solidFill>
+                  <a:srgbClr val="FFFFFF"/>
+                </a:solidFill>
+              </a:defRPr>
+            </a:pPr>
+            <a:r>
+              <a:t>✔ Multi-Currency &amp; Zero-Coin Vouchers: </a:t>
+            </a:r>
+            <a:r>
+              <a:rPr b="0">
+                <a:solidFill>
+                  <a:srgbClr val="94A3B8"/>
+                </a:solidFill>
+              </a:rPr>
+              <a:t>Native ISO standard ZiG/ZWG, USD, and ZAR settlement with cryptographic offline change vouchers.</a:t>
+            </a:r>
+          </a:p>
+          <a:p>
+            <a:pPr>
+              <a:spcAft>
+                <a:spcPts val="1000"/>
+              </a:spcAft>
+              <a:defRPr b="1" sz="1300">
+                <a:solidFill>
+                  <a:srgbClr val="FFFFFF"/>
+                </a:solidFill>
+              </a:defRPr>
+            </a:pPr>
+            <a:r>
+              <a:t>✔ One-Command Bootstrap: </a:t>
+            </a:r>
+            <a:r>
+              <a:rPr b="0">
+                <a:solidFill>
+                  <a:srgbClr val="94A3B8"/>
+                </a:solidFill>
+              </a:rPr>
+              <a:t>Execute 'python start.py' on any laptop, Raspberry Pi, or server to launch the full autonomous cluster.</a:t>
+            </a:r>
+          </a:p>
+          <a:p>
+            <a:pPr>
+              <a:spcAft>
+                <a:spcPts val="1000"/>
+              </a:spcAft>
+              <a:defRPr b="1" sz="1300">
+                <a:solidFill>
+                  <a:srgbClr val="FFFFFF"/>
+                </a:solidFill>
+              </a:defRPr>
+            </a:pPr>
+            <a:r>
+              <a:t>✔ Next Development Milestone (Cycle 5): </a:t>
+            </a:r>
+            <a:r>
+              <a:rPr b="0">
+                <a:solidFill>
+                  <a:srgbClr val="94A3B8"/>
+                </a:solidFill>
+              </a:rPr>
+              <a:t>Bidirectional P2P vector delta mesh sync and captive Wi-Fi portal access vending on receipts.</a:t>
+            </a:r>
+          </a:p>
+          <a:p>
+            <a:pPr>
+              <a:defRPr sz="1400" b="1">
+                <a:solidFill>
+                  <a:srgbClr val="F59E0B"/>
+                </a:solidFill>
+              </a:defRPr>
+            </a:pPr>
+            <a:r>
+              <a:t>MADN — Sovereign Data • Resilient Trade • Continuous Value</a:t>
             </a:r>
           </a:p>
         </p:txBody>
@@ -3317,7 +4029,7 @@
           <a:lstStyle/>
           <a:p>
             <a:pPr>
-              <a:defRPr sz="2400" b="1">
+              <a:defRPr sz="2300" b="1">
                 <a:solidFill>
                   <a:srgbClr val="FFFFFF"/>
                 </a:solidFill>
@@ -3430,7 +4142,7 @@
                   <a:srgbClr val="94A3B8"/>
                 </a:solidFill>
               </a:rPr>
-              <a:t>64 MB – 128 MB SDRAM ($150+). Barely enough to keep a browser tab in memory.</a:t>
+              <a:t>64 MB – 128 MB SDRAM ($150+). Barely enough to keep a single application in memory.</a:t>
             </a:r>
           </a:p>
           <a:p>
@@ -3522,7 +4234,7 @@
                   <a:srgbClr val="94A3B8"/>
                 </a:solidFill>
               </a:rPr>
-              <a:t>Centralized server farms were mandatory because client devices were too weak to process data.</a:t>
+              <a:t>Centralized server farms were mandatory because client devices were too weak to compute.</a:t>
             </a:r>
           </a:p>
         </p:txBody>
@@ -3809,14 +4521,14 @@
           <a:lstStyle/>
           <a:p>
             <a:pPr>
-              <a:defRPr sz="2400" b="1">
+              <a:defRPr sz="2300" b="1">
                 <a:solidFill>
                   <a:srgbClr val="FFFFFF"/>
                 </a:solidFill>
               </a:defRPr>
             </a:pPr>
             <a:r>
-              <a:t>The Idle Infrastructure Paradox &amp; The Cloud Trap</a:t>
+              <a:t>Problem Statement: Centralized Cloud Vulnerabilities &amp; Local Friction</a:t>
             </a:r>
           </a:p>
         </p:txBody>
@@ -3830,120 +4542,7 @@
         <p:spPr>
           <a:xfrm>
             <a:off x="731520" y="1463040"/>
-            <a:ext cx="3328416" cy="4663440"/>
-          </a:xfrm>
-          <a:prstGeom prst="roundRect">
-            <a:avLst/>
-          </a:prstGeom>
-          <a:solidFill>
-            <a:srgbClr val="111827"/>
-          </a:solidFill>
-          <a:ln w="19050">
-            <a:solidFill>
-              <a:srgbClr val="1F2937"/>
-            </a:solidFill>
-          </a:ln>
-        </p:spPr>
-        <p:style>
-          <a:lnRef idx="1">
-            <a:schemeClr val="accent1"/>
-          </a:lnRef>
-          <a:fillRef idx="3">
-            <a:schemeClr val="accent1"/>
-          </a:fillRef>
-          <a:effectRef idx="2">
-            <a:schemeClr val="accent1"/>
-          </a:effectRef>
-          <a:fontRef idx="minor">
-            <a:schemeClr val="lt1"/>
-          </a:fontRef>
-        </p:style>
-        <p:txBody>
-          <a:bodyPr rtlCol="0" anchor="ctr"/>
-          <a:lstStyle/>
-          <a:p>
-            <a:pPr algn="ctr"/>
-          </a:p>
-        </p:txBody>
-      </p:sp>
-      <p:sp>
-        <p:nvSpPr>
-          <p:cNvPr id="5" name="TextBox 4"/>
-          <p:cNvSpPr txBox="1"/>
-          <p:nvPr/>
-        </p:nvSpPr>
-        <p:spPr>
-          <a:xfrm>
-            <a:off x="914400" y="1645920"/>
-            <a:ext cx="2962656" cy="4297680"/>
-          </a:xfrm>
-          <a:prstGeom prst="rect">
-            <a:avLst/>
-          </a:prstGeom>
-          <a:noFill/>
-        </p:spPr>
-        <p:txBody>
-          <a:bodyPr wrap="square">
-            <a:spAutoFit/>
-          </a:bodyPr>
-          <a:lstStyle/>
-          <a:p>
-            <a:pPr>
-              <a:spcAft>
-                <a:spcPts val="1200"/>
-              </a:spcAft>
-              <a:defRPr sz="1700" b="1">
-                <a:solidFill>
-                  <a:srgbClr val="F59E0B"/>
-                </a:solidFill>
-              </a:defRPr>
-            </a:pPr>
-            <a:r>
-              <a:t>💤 85%+ Idle Capacity</a:t>
-            </a:r>
-          </a:p>
-          <a:p>
-            <a:pPr>
-              <a:defRPr sz="1200">
-                <a:solidFill>
-                  <a:srgbClr val="94A3B8"/>
-                </a:solidFill>
-              </a:defRPr>
-            </a:pPr>
-            <a:r>
-              <a:t>Billions of smartphones, Raspberry Pis, POS terminals, and laptops run at &lt; 15% CPU utilization.</a:t>
-            </a:r>
-            <a:br/>
-            <a:br/>
-            <a:r>
-              <a:t>• Gigabytes of high-speed RAM sit dormant.</a:t>
-            </a:r>
-            <a:br/>
-            <a:r>
-              <a:t>• Multi-core ARM/x86 processors sleep.</a:t>
-            </a:r>
-            <a:br/>
-            <a:r>
-              <a:t>• Terabytes of ultra-fast NVMe storage remain empty.</a:t>
-            </a:r>
-            <a:br/>
-            <a:br/>
-            <a:r>
-              <a:t>We own supercomputers, yet we pay third parties to compute for us.</a:t>
-            </a:r>
-          </a:p>
-        </p:txBody>
-      </p:sp>
-      <p:sp>
-        <p:nvSpPr>
-          <p:cNvPr id="6" name="Rounded Rectangle 5"/>
-          <p:cNvSpPr/>
-          <p:nvPr/>
-        </p:nvSpPr>
-        <p:spPr>
-          <a:xfrm>
-            <a:off x="4425696" y="1463040"/>
-            <a:ext cx="3328416" cy="4663440"/>
+            <a:ext cx="5120640" cy="2286000"/>
           </a:xfrm>
           <a:prstGeom prst="roundRect">
             <a:avLst/>
@@ -3981,14 +4580,14 @@
       </p:sp>
       <p:sp>
         <p:nvSpPr>
-          <p:cNvPr id="7" name="TextBox 6"/>
+          <p:cNvPr id="5" name="TextBox 4"/>
           <p:cNvSpPr txBox="1"/>
           <p:nvPr/>
         </p:nvSpPr>
         <p:spPr>
           <a:xfrm>
-            <a:off x="4608576" y="1645920"/>
-            <a:ext cx="2962656" cy="4297680"/>
+            <a:off x="914400" y="1600200"/>
+            <a:ext cx="4754880" cy="2011680"/>
           </a:xfrm>
           <a:prstGeom prst="rect">
             <a:avLst/>
@@ -4003,45 +4602,191 @@
           <a:p>
             <a:pPr>
               <a:spcAft>
-                <a:spcPts val="1200"/>
+                <a:spcPts val="600"/>
               </a:spcAft>
-              <a:defRPr sz="1700" b="1">
+              <a:defRPr sz="1450" b="1">
                 <a:solidFill>
                   <a:srgbClr val="EF4444"/>
                 </a:solidFill>
               </a:defRPr>
             </a:pPr>
             <a:r>
-              <a:t>💸 The Cloud Tax &amp; Fragility</a:t>
-            </a:r>
-          </a:p>
-          <a:p>
-            <a:pPr>
-              <a:defRPr sz="1200">
+              <a:t>🌐 1. WAN &amp; Internet Dependency Trap</a:t>
+            </a:r>
+          </a:p>
+          <a:p>
+            <a:pPr>
+              <a:spcAft>
+                <a:spcPts val="400"/>
+              </a:spcAft>
+              <a:defRPr b="1" sz="1050">
+                <a:solidFill>
+                  <a:srgbClr val="FFFFFF"/>
+                </a:solidFill>
+              </a:defRPr>
+            </a:pPr>
+            <a:r>
+              <a:t>• Single Points of Failure: </a:t>
+            </a:r>
+            <a:r>
+              <a:rPr b="0">
                 <a:solidFill>
                   <a:srgbClr val="94A3B8"/>
                 </a:solidFill>
-              </a:defRPr>
-            </a:pPr>
-            <a:r>
-              <a:t>Centralized cloud architectures create economic rent and single points of failure:</a:t>
-            </a:r>
-            <a:br/>
-            <a:br/>
-            <a:r>
-              <a:t>• Recurring monthly SaaS subscriptions.</a:t>
-            </a:r>
-            <a:br/>
-            <a:r>
-              <a:t>• High data egress &amp; API gateway tolls.</a:t>
-            </a:r>
-            <a:br/>
-            <a:r>
-              <a:t>• Single fiber cuts or outages paralyze local shops and farm markets.</a:t>
-            </a:r>
-            <a:br/>
-            <a:r>
-              <a:t>• Surveillance and loss of data sovereignty.</a:t>
+              </a:rPr>
+              <a:t>Reliance on distant cloud servers causes total point-of-sale and transaction collapse during fiber cuts, ISP blackouts, or local power grid instability.</a:t>
+            </a:r>
+          </a:p>
+          <a:p>
+            <a:pPr>
+              <a:spcAft>
+                <a:spcPts val="400"/>
+              </a:spcAft>
+              <a:defRPr b="1" sz="1050">
+                <a:solidFill>
+                  <a:srgbClr val="FFFFFF"/>
+                </a:solidFill>
+              </a:defRPr>
+            </a:pPr>
+            <a:r>
+              <a:t>• Latency &amp; Cost Inefficiency: </a:t>
+            </a:r>
+            <a:r>
+              <a:rPr b="0">
+                <a:solidFill>
+                  <a:srgbClr val="94A3B8"/>
+                </a:solidFill>
+              </a:rPr>
+              <a:t>Local micro-transactions travel thousands of kilometers across global backbones, incurring high egress tolls and unacceptable network delays.</a:t>
+            </a:r>
+          </a:p>
+        </p:txBody>
+      </p:sp>
+      <p:sp>
+        <p:nvSpPr>
+          <p:cNvPr id="6" name="Rounded Rectangle 5"/>
+          <p:cNvSpPr/>
+          <p:nvPr/>
+        </p:nvSpPr>
+        <p:spPr>
+          <a:xfrm>
+            <a:off x="6309360" y="1463040"/>
+            <a:ext cx="5120640" cy="2286000"/>
+          </a:xfrm>
+          <a:prstGeom prst="roundRect">
+            <a:avLst/>
+          </a:prstGeom>
+          <a:solidFill>
+            <a:srgbClr val="111827"/>
+          </a:solidFill>
+          <a:ln w="19050">
+            <a:solidFill>
+              <a:srgbClr val="F59E0B"/>
+            </a:solidFill>
+          </a:ln>
+        </p:spPr>
+        <p:style>
+          <a:lnRef idx="1">
+            <a:schemeClr val="accent1"/>
+          </a:lnRef>
+          <a:fillRef idx="3">
+            <a:schemeClr val="accent1"/>
+          </a:fillRef>
+          <a:effectRef idx="2">
+            <a:schemeClr val="accent1"/>
+          </a:effectRef>
+          <a:fontRef idx="minor">
+            <a:schemeClr val="lt1"/>
+          </a:fontRef>
+        </p:style>
+        <p:txBody>
+          <a:bodyPr rtlCol="0" anchor="ctr"/>
+          <a:lstStyle/>
+          <a:p>
+            <a:pPr algn="ctr"/>
+          </a:p>
+        </p:txBody>
+      </p:sp>
+      <p:sp>
+        <p:nvSpPr>
+          <p:cNvPr id="7" name="TextBox 6"/>
+          <p:cNvSpPr txBox="1"/>
+          <p:nvPr/>
+        </p:nvSpPr>
+        <p:spPr>
+          <a:xfrm>
+            <a:off x="6492240" y="1600200"/>
+            <a:ext cx="4754880" cy="2011680"/>
+          </a:xfrm>
+          <a:prstGeom prst="rect">
+            <a:avLst/>
+          </a:prstGeom>
+          <a:noFill/>
+        </p:spPr>
+        <p:txBody>
+          <a:bodyPr wrap="square">
+            <a:spAutoFit/>
+          </a:bodyPr>
+          <a:lstStyle/>
+          <a:p>
+            <a:pPr>
+              <a:spcAft>
+                <a:spcPts val="600"/>
+              </a:spcAft>
+              <a:defRPr sz="1450" b="1">
+                <a:solidFill>
+                  <a:srgbClr val="F59E0B"/>
+                </a:solidFill>
+              </a:defRPr>
+            </a:pPr>
+            <a:r>
+              <a:t>💱 2. Multi-Currency Friction &amp; Coin Scarcity</a:t>
+            </a:r>
+          </a:p>
+          <a:p>
+            <a:pPr>
+              <a:spcAft>
+                <a:spcPts val="400"/>
+              </a:spcAft>
+              <a:defRPr b="1" sz="1050">
+                <a:solidFill>
+                  <a:srgbClr val="FFFFFF"/>
+                </a:solidFill>
+              </a:defRPr>
+            </a:pPr>
+            <a:r>
+              <a:t>• Small Change Crisis: </a:t>
+            </a:r>
+            <a:r>
+              <a:rPr b="0">
+                <a:solidFill>
+                  <a:srgbClr val="94A3B8"/>
+                </a:solidFill>
+              </a:rPr>
+              <a:t>In multi-currency regimes (USD, ZAR, Zimbabwe Gold ZiG), physical small-denomination coins are perpetually scarce, stalling retail commerce.</a:t>
+            </a:r>
+          </a:p>
+          <a:p>
+            <a:pPr>
+              <a:spcAft>
+                <a:spcPts val="400"/>
+              </a:spcAft>
+              <a:defRPr b="1" sz="1050">
+                <a:solidFill>
+                  <a:srgbClr val="FFFFFF"/>
+                </a:solidFill>
+              </a:defRPr>
+            </a:pPr>
+            <a:r>
+              <a:t>• Forced Overpayments: </a:t>
+            </a:r>
+            <a:r>
+              <a:rPr b="0">
+                <a:solidFill>
+                  <a:srgbClr val="94A3B8"/>
+                </a:solidFill>
+              </a:rPr>
+              <a:t>Shoppers are forced into arbitrary unwanted purchases (sweets, matches) or loose change forfeit, eroding purchasing power and merchant trust.</a:t>
             </a:r>
           </a:p>
         </p:txBody>
@@ -4054,8 +4799,137 @@
         </p:nvSpPr>
         <p:spPr>
           <a:xfrm>
-            <a:off x="8119872" y="1463040"/>
-            <a:ext cx="3328416" cy="4663440"/>
+            <a:off x="731520" y="3931920"/>
+            <a:ext cx="5120640" cy="2286000"/>
+          </a:xfrm>
+          <a:prstGeom prst="roundRect">
+            <a:avLst/>
+          </a:prstGeom>
+          <a:solidFill>
+            <a:srgbClr val="111827"/>
+          </a:solidFill>
+          <a:ln w="19050">
+            <a:solidFill>
+              <a:srgbClr val="7C4DFF"/>
+            </a:solidFill>
+          </a:ln>
+        </p:spPr>
+        <p:style>
+          <a:lnRef idx="1">
+            <a:schemeClr val="accent1"/>
+          </a:lnRef>
+          <a:fillRef idx="3">
+            <a:schemeClr val="accent1"/>
+          </a:fillRef>
+          <a:effectRef idx="2">
+            <a:schemeClr val="accent1"/>
+          </a:effectRef>
+          <a:fontRef idx="minor">
+            <a:schemeClr val="lt1"/>
+          </a:fontRef>
+        </p:style>
+        <p:txBody>
+          <a:bodyPr rtlCol="0" anchor="ctr"/>
+          <a:lstStyle/>
+          <a:p>
+            <a:pPr algn="ctr"/>
+          </a:p>
+        </p:txBody>
+      </p:sp>
+      <p:sp>
+        <p:nvSpPr>
+          <p:cNvPr id="9" name="TextBox 8"/>
+          <p:cNvSpPr txBox="1"/>
+          <p:nvPr/>
+        </p:nvSpPr>
+        <p:spPr>
+          <a:xfrm>
+            <a:off x="914400" y="4069080"/>
+            <a:ext cx="4754880" cy="2011680"/>
+          </a:xfrm>
+          <a:prstGeom prst="rect">
+            <a:avLst/>
+          </a:prstGeom>
+          <a:noFill/>
+        </p:spPr>
+        <p:txBody>
+          <a:bodyPr wrap="square">
+            <a:spAutoFit/>
+          </a:bodyPr>
+          <a:lstStyle/>
+          <a:p>
+            <a:pPr>
+              <a:spcAft>
+                <a:spcPts val="600"/>
+              </a:spcAft>
+              <a:defRPr sz="1450" b="1">
+                <a:solidFill>
+                  <a:srgbClr val="7C4DFF"/>
+                </a:solidFill>
+              </a:defRPr>
+            </a:pPr>
+            <a:r>
+              <a:t>🌾 3. Static Pricing &amp; Perishable Food Spoilage</a:t>
+            </a:r>
+          </a:p>
+          <a:p>
+            <a:pPr>
+              <a:spcAft>
+                <a:spcPts val="400"/>
+              </a:spcAft>
+              <a:defRPr b="1" sz="1050">
+                <a:solidFill>
+                  <a:srgbClr val="FFFFFF"/>
+                </a:solidFill>
+              </a:defRPr>
+            </a:pPr>
+            <a:r>
+              <a:t>• Inventory Depreciation: </a:t>
+            </a:r>
+            <a:r>
+              <a:rPr b="0">
+                <a:solidFill>
+                  <a:srgbClr val="94A3B8"/>
+                </a:solidFill>
+              </a:rPr>
+              <a:t>Fresh agricultural produce (tomatoes, dairy, leafy greens) depreciates rapidly, but conventional static POS systems fail to adjust prices dynamically.</a:t>
+            </a:r>
+          </a:p>
+          <a:p>
+            <a:pPr>
+              <a:spcAft>
+                <a:spcPts val="400"/>
+              </a:spcAft>
+              <a:defRPr b="1" sz="1050">
+                <a:solidFill>
+                  <a:srgbClr val="FFFFFF"/>
+                </a:solidFill>
+              </a:defRPr>
+            </a:pPr>
+            <a:r>
+              <a:t>• Economic Deadweight Loss: </a:t>
+            </a:r>
+            <a:r>
+              <a:rPr b="0">
+                <a:solidFill>
+                  <a:srgbClr val="94A3B8"/>
+                </a:solidFill>
+              </a:rPr>
+              <a:t>Lack of autonomous, shelf-life-aware algorithmic discounting results in massive spoilage, food wastage, and merchant revenue erosion.</a:t>
+            </a:r>
+          </a:p>
+        </p:txBody>
+      </p:sp>
+      <p:sp>
+        <p:nvSpPr>
+          <p:cNvPr id="10" name="Rounded Rectangle 9"/>
+          <p:cNvSpPr/>
+          <p:nvPr/>
+        </p:nvSpPr>
+        <p:spPr>
+          <a:xfrm>
+            <a:off x="6309360" y="3931920"/>
+            <a:ext cx="5120640" cy="2286000"/>
           </a:xfrm>
           <a:prstGeom prst="roundRect">
             <a:avLst/>
@@ -4093,14 +4967,14 @@
       </p:sp>
       <p:sp>
         <p:nvSpPr>
-          <p:cNvPr id="9" name="TextBox 8"/>
+          <p:cNvPr id="11" name="TextBox 10"/>
           <p:cNvSpPr txBox="1"/>
           <p:nvPr/>
         </p:nvSpPr>
         <p:spPr>
           <a:xfrm>
-            <a:off x="8302752" y="1645920"/>
-            <a:ext cx="2962656" cy="4297680"/>
+            <a:off x="6492240" y="4069080"/>
+            <a:ext cx="4754880" cy="2011680"/>
           </a:xfrm>
           <a:prstGeom prst="rect">
             <a:avLst/>
@@ -4115,45 +4989,62 @@
           <a:p>
             <a:pPr>
               <a:spcAft>
-                <a:spcPts val="1200"/>
+                <a:spcPts val="600"/>
               </a:spcAft>
-              <a:defRPr sz="1700" b="1">
+              <a:defRPr sz="1450" b="1">
                 <a:solidFill>
                   <a:srgbClr val="00E5FF"/>
                 </a:solidFill>
               </a:defRPr>
             </a:pPr>
             <a:r>
-              <a:t>💡 The MADN Solution</a:t>
-            </a:r>
-          </a:p>
-          <a:p>
-            <a:pPr>
-              <a:defRPr sz="1200">
+              <a:t>🔒 4. Cloud Surveillance &amp; Sovereign Data Loss</a:t>
+            </a:r>
+          </a:p>
+          <a:p>
+            <a:pPr>
+              <a:spcAft>
+                <a:spcPts val="400"/>
+              </a:spcAft>
+              <a:defRPr b="1" sz="1050">
+                <a:solidFill>
+                  <a:srgbClr val="FFFFFF"/>
+                </a:solidFill>
+              </a:defRPr>
+            </a:pPr>
+            <a:r>
+              <a:t>• Vendor Lock-in &amp; Data Leakage: </a:t>
+            </a:r>
+            <a:r>
+              <a:rPr b="0">
                 <a:solidFill>
                   <a:srgbClr val="94A3B8"/>
                 </a:solidFill>
-              </a:defRPr>
-            </a:pPr>
-            <a:r>
-              <a:t>Turn existing idle hardware into autonomous, peer-to-peer data and financial nodes:</a:t>
-            </a:r>
-            <a:br/>
-            <a:br/>
-            <a:r>
-              <a:t>• Zero cloud subscriptions or external hosting.</a:t>
-            </a:r>
-            <a:br/>
-            <a:r>
-              <a:t>• 100% offline air-gapped continuity.</a:t>
-            </a:r>
-            <a:br/>
-            <a:r>
-              <a:t>• Free, instant local network transfers.</a:t>
-            </a:r>
-            <a:br/>
-            <a:r>
-              <a:t>• Autonomous local value generation for farmers, merchants, and communities.</a:t>
+              </a:rPr>
+              <a:t>Small businesses and agricultural communities surrender sensitive financial logs and operational telemetry to foreign SaaS platforms.</a:t>
+            </a:r>
+          </a:p>
+          <a:p>
+            <a:pPr>
+              <a:spcAft>
+                <a:spcPts val="400"/>
+              </a:spcAft>
+              <a:defRPr b="1" sz="1050">
+                <a:solidFill>
+                  <a:srgbClr val="FFFFFF"/>
+                </a:solidFill>
+              </a:defRPr>
+            </a:pPr>
+            <a:r>
+              <a:t>• Recurring SaaS Rent: </a:t>
+            </a:r>
+            <a:r>
+              <a:rPr b="0">
+                <a:solidFill>
+                  <a:srgbClr val="94A3B8"/>
+                </a:solidFill>
+              </a:rPr>
+              <a:t>Escalating monthly software subscriptions drain working capital from developing edge economies while offering zero offline operational resilience.</a:t>
             </a:r>
           </a:p>
         </p:txBody>
@@ -4242,14 +5133,14 @@
           <a:lstStyle/>
           <a:p>
             <a:pPr>
-              <a:defRPr sz="2400" b="1">
+              <a:defRPr sz="2300" b="1">
                 <a:solidFill>
                   <a:srgbClr val="FFFFFF"/>
                 </a:solidFill>
               </a:defRPr>
             </a:pPr>
             <a:r>
-              <a:t>Tri-Node Sovereign Architecture: Modular &amp; Composable</a:t>
+              <a:t>Research Objectives: Engineering Sovereign Edge Valuation</a:t>
             </a:r>
           </a:p>
         </p:txBody>
@@ -4262,8 +5153,8 @@
         </p:nvSpPr>
         <p:spPr>
           <a:xfrm>
-            <a:off x="731520" y="1463040"/>
-            <a:ext cx="3328416" cy="4663440"/>
+            <a:off x="731520" y="1371600"/>
+            <a:ext cx="10728655" cy="1051560"/>
           </a:xfrm>
           <a:prstGeom prst="roundRect">
             <a:avLst/>
@@ -4273,7 +5164,7 @@
           </a:solidFill>
           <a:ln w="19050">
             <a:solidFill>
-              <a:srgbClr val="1F2937"/>
+              <a:srgbClr val="00E5FF"/>
             </a:solidFill>
           </a:ln>
         </p:spPr>
@@ -4307,8 +5198,8 @@
         </p:nvSpPr>
         <p:spPr>
           <a:xfrm>
-            <a:off x="914400" y="1645920"/>
-            <a:ext cx="2962656" cy="4297680"/>
+            <a:off x="914400" y="1417320"/>
+            <a:ext cx="10362895" cy="914400"/>
           </a:xfrm>
           <a:prstGeom prst="rect">
             <a:avLst/>
@@ -4322,46 +5213,26 @@
           <a:lstStyle/>
           <a:p>
             <a:pPr>
-              <a:spcAft>
-                <a:spcPts val="1000"/>
-              </a:spcAft>
-              <a:defRPr sz="1600" b="1">
+              <a:defRPr sz="1200" b="1">
                 <a:solidFill>
                   <a:srgbClr val="00E5FF"/>
                 </a:solidFill>
               </a:defRPr>
             </a:pPr>
             <a:r>
-              <a:t>🖥️ 1. Operator Node (:8000)</a:t>
+              <a:t>🎯 PRIMARY RESEARCH OBJECTIVE</a:t>
             </a:r>
           </a:p>
           <a:p>
             <a:pPr>
               <a:defRPr sz="1150">
                 <a:solidFill>
-                  <a:srgbClr val="94A3B8"/>
-                </a:solidFill>
-              </a:defRPr>
-            </a:pPr>
-            <a:r>
-              <a:t>Zero-installation VisionPro Dark Glass Web Client executing in any modern browser.</a:t>
-            </a:r>
-            <a:br/>
-            <a:br/>
-            <a:r>
-              <a:t>• Dynamic real-time touch POS register.</a:t>
-            </a:r>
-            <a:br/>
-            <a:r>
-              <a:t>• Organic concentric glowing avatar profiles with client-side image compression.</a:t>
-            </a:r>
-            <a:br/>
-            <a:r>
-              <a:t>• Condition-gated progressive disclosure (Store Setup -&gt; POS -&gt; Marketplace).</a:t>
-            </a:r>
-            <a:br/>
-            <a:r>
-              <a:t>• Digital Receipt Vault &amp; QR scanner.</a:t>
+                  <a:srgbClr val="FFFFFF"/>
+                </a:solidFill>
+              </a:defRPr>
+            </a:pPr>
+            <a:r>
+              <a:t>To architect, develop, and empirically validate an offline-first Modular Adaptive Data Node (MADN) ecosystem that leverages idle commodity edge hardware and local high-bandwidth wireless mesh to enable autonomous, tamper-evident dynamic valuation, multi-tender settlement, and closed-loop agro-industrial tracking.</a:t>
             </a:r>
           </a:p>
         </p:txBody>
@@ -4374,8 +5245,8 @@
         </p:nvSpPr>
         <p:spPr>
           <a:xfrm>
-            <a:off x="4425696" y="1463040"/>
-            <a:ext cx="3328416" cy="4663440"/>
+            <a:off x="731520" y="2560320"/>
+            <a:ext cx="2514600" cy="3749039"/>
           </a:xfrm>
           <a:prstGeom prst="roundRect">
             <a:avLst/>
@@ -4385,7 +5256,7 @@
           </a:solidFill>
           <a:ln w="19050">
             <a:solidFill>
-              <a:srgbClr val="1F2937"/>
+              <a:srgbClr val="00E5FF"/>
             </a:solidFill>
           </a:ln>
         </p:spPr>
@@ -4419,8 +5290,8 @@
         </p:nvSpPr>
         <p:spPr>
           <a:xfrm>
-            <a:off x="4608576" y="1645920"/>
-            <a:ext cx="2962656" cy="4297680"/>
+            <a:off x="868680" y="2697480"/>
+            <a:ext cx="2240280" cy="3474719"/>
           </a:xfrm>
           <a:prstGeom prst="rect">
             <a:avLst/>
@@ -4435,45 +5306,85 @@
           <a:p>
             <a:pPr>
               <a:spcAft>
-                <a:spcPts val="1000"/>
+                <a:spcPts val="800"/>
               </a:spcAft>
-              <a:defRPr sz="1600" b="1">
-                <a:solidFill>
-                  <a:srgbClr val="7C4DFF"/>
-                </a:solidFill>
-              </a:defRPr>
-            </a:pPr>
-            <a:r>
-              <a:t>📡 2. Data Node (:8002)</a:t>
-            </a:r>
-          </a:p>
-          <a:p>
-            <a:pPr>
-              <a:defRPr sz="1150">
+              <a:defRPr sz="1350" b="1">
+                <a:solidFill>
+                  <a:srgbClr val="00E5FF"/>
+                </a:solidFill>
+              </a:defRPr>
+            </a:pPr>
+            <a:r>
+              <a:t>RO-1: Tri-Node Edge Mesh Architecture</a:t>
+            </a:r>
+          </a:p>
+          <a:p>
+            <a:pPr>
+              <a:spcAft>
+                <a:spcPts val="600"/>
+              </a:spcAft>
+              <a:defRPr b="1" sz="1050">
+                <a:solidFill>
+                  <a:srgbClr val="FFFFFF"/>
+                </a:solidFill>
+              </a:defRPr>
+            </a:pPr>
+            <a:r>
+              <a:t>• Zero-Cloud Decoupling: </a:t>
+            </a:r>
+            <a:r>
+              <a:rPr b="0">
                 <a:solidFill>
                   <a:srgbClr val="94A3B8"/>
                 </a:solidFill>
-              </a:defRPr>
-            </a:pPr>
-            <a:r>
-              <a:t>Standalone storage, multicast peer discovery, and global currency collector.</a:t>
-            </a:r>
-            <a:br/>
-            <a:br/>
-            <a:r>
-              <a:t>• UDP Multicast Heartbeats (224.0.0.251:8001) for zero-config local mesh discovery.</a:t>
-            </a:r>
-            <a:br/>
-            <a:r>
-              <a:t>• 170+ ISO Fiat &amp; 50+ Crypto Currency Catalog with air-gapped fallback.</a:t>
-            </a:r>
-            <a:br/>
-            <a:r>
-              <a:t>• Encrypted Key-Value store with AES-256-GCM data-at-rest protection.</a:t>
-            </a:r>
-            <a:br/>
-            <a:r>
-              <a:t>• Remote lifecycle &amp; maintenance controls.</a:t>
+              </a:rPr>
+              <a:t>Engineer an autonomous tri-node separation (Operator, Data Node, Vault Node).</a:t>
+            </a:r>
+          </a:p>
+          <a:p>
+            <a:pPr>
+              <a:spcAft>
+                <a:spcPts val="600"/>
+              </a:spcAft>
+              <a:defRPr b="1" sz="1050">
+                <a:solidFill>
+                  <a:srgbClr val="FFFFFF"/>
+                </a:solidFill>
+              </a:defRPr>
+            </a:pPr>
+            <a:r>
+              <a:t>• Multicast Mesh: </a:t>
+            </a:r>
+            <a:r>
+              <a:rPr b="0">
+                <a:solidFill>
+                  <a:srgbClr val="94A3B8"/>
+                </a:solidFill>
+              </a:rPr>
+              <a:t>Implement zero-config UDP multicast peer discovery (224.0.0.251:8001).</a:t>
+            </a:r>
+          </a:p>
+          <a:p>
+            <a:pPr>
+              <a:spcAft>
+                <a:spcPts val="600"/>
+              </a:spcAft>
+              <a:defRPr b="1" sz="1050">
+                <a:solidFill>
+                  <a:srgbClr val="FFFFFF"/>
+                </a:solidFill>
+              </a:defRPr>
+            </a:pPr>
+            <a:r>
+              <a:t>• ACID Concurrency: </a:t>
+            </a:r>
+            <a:r>
+              <a:rPr b="0">
+                <a:solidFill>
+                  <a:srgbClr val="94A3B8"/>
+                </a:solidFill>
+              </a:rPr>
+              <a:t>Deliver sub-millisecond SQLite WAL transaction throughput under multi-terminal load.</a:t>
             </a:r>
           </a:p>
         </p:txBody>
@@ -4486,8 +5397,8 @@
         </p:nvSpPr>
         <p:spPr>
           <a:xfrm>
-            <a:off x="8119872" y="1463040"/>
-            <a:ext cx="3328416" cy="4663440"/>
+            <a:off x="3456432" y="2560320"/>
+            <a:ext cx="2514600" cy="3749039"/>
           </a:xfrm>
           <a:prstGeom prst="roundRect">
             <a:avLst/>
@@ -4497,7 +5408,7 @@
           </a:solidFill>
           <a:ln w="19050">
             <a:solidFill>
-              <a:srgbClr val="1F2937"/>
+              <a:srgbClr val="F59E0B"/>
             </a:solidFill>
           </a:ln>
         </p:spPr>
@@ -4531,8 +5442,8 @@
         </p:nvSpPr>
         <p:spPr>
           <a:xfrm>
-            <a:off x="8302752" y="1645920"/>
-            <a:ext cx="2962656" cy="4297680"/>
+            <a:off x="3593592" y="2697480"/>
+            <a:ext cx="2240280" cy="3474719"/>
           </a:xfrm>
           <a:prstGeom prst="rect">
             <a:avLst/>
@@ -4547,45 +5458,389 @@
           <a:p>
             <a:pPr>
               <a:spcAft>
-                <a:spcPts val="1000"/>
+                <a:spcPts val="800"/>
               </a:spcAft>
-              <a:defRPr sz="1600" b="1">
+              <a:defRPr sz="1350" b="1">
+                <a:solidFill>
+                  <a:srgbClr val="F59E0B"/>
+                </a:solidFill>
+              </a:defRPr>
+            </a:pPr>
+            <a:r>
+              <a:t>RO-2: Dynamic Value &amp; Pricing Engine</a:t>
+            </a:r>
+          </a:p>
+          <a:p>
+            <a:pPr>
+              <a:spcAft>
+                <a:spcPts val="600"/>
+              </a:spcAft>
+              <a:defRPr b="1" sz="1050">
+                <a:solidFill>
+                  <a:srgbClr val="FFFFFF"/>
+                </a:solidFill>
+              </a:defRPr>
+            </a:pPr>
+            <a:r>
+              <a:t>• Perishable Decay: </a:t>
+            </a:r>
+            <a:r>
+              <a:rPr b="0">
+                <a:solidFill>
+                  <a:srgbClr val="94A3B8"/>
+                </a:solidFill>
+              </a:rPr>
+              <a:t>Formulate real-time continuous exponential price decay algorithms: P(t) = P_cost + (P_base - P_cost)e^(-λt).</a:t>
+            </a:r>
+          </a:p>
+          <a:p>
+            <a:pPr>
+              <a:spcAft>
+                <a:spcPts val="600"/>
+              </a:spcAft>
+              <a:defRPr b="1" sz="1050">
+                <a:solidFill>
+                  <a:srgbClr val="FFFFFF"/>
+                </a:solidFill>
+              </a:defRPr>
+            </a:pPr>
+            <a:r>
+              <a:t>• Split-Tender Settlement: </a:t>
+            </a:r>
+            <a:r>
+              <a:rPr b="0">
+                <a:solidFill>
+                  <a:srgbClr val="94A3B8"/>
+                </a:solidFill>
+              </a:rPr>
+              <a:t>Compute multi-currency basket checkouts across USD, ZAR, and Zimbabwe Gold (ZiG).</a:t>
+            </a:r>
+          </a:p>
+          <a:p>
+            <a:pPr>
+              <a:spcAft>
+                <a:spcPts val="600"/>
+              </a:spcAft>
+              <a:defRPr b="1" sz="1050">
+                <a:solidFill>
+                  <a:srgbClr val="FFFFFF"/>
+                </a:solidFill>
+              </a:defRPr>
+            </a:pPr>
+            <a:r>
+              <a:t>• Cryptographic Vouchers: </a:t>
+            </a:r>
+            <a:r>
+              <a:rPr b="0">
+                <a:solidFill>
+                  <a:srgbClr val="94A3B8"/>
+                </a:solidFill>
+              </a:rPr>
+              <a:t>Mint offline HMAC-SHA256 QR change vouchers to eliminate physical coin shortages.</a:t>
+            </a:r>
+          </a:p>
+        </p:txBody>
+      </p:sp>
+      <p:sp>
+        <p:nvSpPr>
+          <p:cNvPr id="10" name="Rounded Rectangle 9"/>
+          <p:cNvSpPr/>
+          <p:nvPr/>
+        </p:nvSpPr>
+        <p:spPr>
+          <a:xfrm>
+            <a:off x="6181344" y="2560320"/>
+            <a:ext cx="2514600" cy="3749039"/>
+          </a:xfrm>
+          <a:prstGeom prst="roundRect">
+            <a:avLst/>
+          </a:prstGeom>
+          <a:solidFill>
+            <a:srgbClr val="111827"/>
+          </a:solidFill>
+          <a:ln w="19050">
+            <a:solidFill>
+              <a:srgbClr val="7C4DFF"/>
+            </a:solidFill>
+          </a:ln>
+        </p:spPr>
+        <p:style>
+          <a:lnRef idx="1">
+            <a:schemeClr val="accent1"/>
+          </a:lnRef>
+          <a:fillRef idx="3">
+            <a:schemeClr val="accent1"/>
+          </a:fillRef>
+          <a:effectRef idx="2">
+            <a:schemeClr val="accent1"/>
+          </a:effectRef>
+          <a:fontRef idx="minor">
+            <a:schemeClr val="lt1"/>
+          </a:fontRef>
+        </p:style>
+        <p:txBody>
+          <a:bodyPr rtlCol="0" anchor="ctr"/>
+          <a:lstStyle/>
+          <a:p>
+            <a:pPr algn="ctr"/>
+          </a:p>
+        </p:txBody>
+      </p:sp>
+      <p:sp>
+        <p:nvSpPr>
+          <p:cNvPr id="11" name="TextBox 10"/>
+          <p:cNvSpPr txBox="1"/>
+          <p:nvPr/>
+        </p:nvSpPr>
+        <p:spPr>
+          <a:xfrm>
+            <a:off x="6318504" y="2697480"/>
+            <a:ext cx="2240280" cy="3474719"/>
+          </a:xfrm>
+          <a:prstGeom prst="rect">
+            <a:avLst/>
+          </a:prstGeom>
+          <a:noFill/>
+        </p:spPr>
+        <p:txBody>
+          <a:bodyPr wrap="square">
+            <a:spAutoFit/>
+          </a:bodyPr>
+          <a:lstStyle/>
+          <a:p>
+            <a:pPr>
+              <a:spcAft>
+                <a:spcPts val="800"/>
+              </a:spcAft>
+              <a:defRPr sz="1350" b="1">
+                <a:solidFill>
+                  <a:srgbClr val="7C4DFF"/>
+                </a:solidFill>
+              </a:defRPr>
+            </a:pPr>
+            <a:r>
+              <a:t>RO-3: Closed-Loop Precision Agri-Sync</a:t>
+            </a:r>
+          </a:p>
+          <a:p>
+            <a:pPr>
+              <a:spcAft>
+                <a:spcPts val="600"/>
+              </a:spcAft>
+              <a:defRPr b="1" sz="1050">
+                <a:solidFill>
+                  <a:srgbClr val="FFFFFF"/>
+                </a:solidFill>
+              </a:defRPr>
+            </a:pPr>
+            <a:r>
+              <a:t>• Geospatial Plot Tracking: </a:t>
+            </a:r>
+            <a:r>
+              <a:rPr b="0">
+                <a:solidFill>
+                  <a:srgbClr val="94A3B8"/>
+                </a:solidFill>
+              </a:rPr>
+              <a:t>Map farm plots, soil metrics, and Bulawayo micro-climates.</a:t>
+            </a:r>
+          </a:p>
+          <a:p>
+            <a:pPr>
+              <a:spcAft>
+                <a:spcPts val="600"/>
+              </a:spcAft>
+              <a:defRPr b="1" sz="1050">
+                <a:solidFill>
+                  <a:srgbClr val="FFFFFF"/>
+                </a:solidFill>
+              </a:defRPr>
+            </a:pPr>
+            <a:r>
+              <a:t>• Input Ledgering: </a:t>
+            </a:r>
+            <a:r>
+              <a:rPr b="0">
+                <a:solidFill>
+                  <a:srgbClr val="94A3B8"/>
+                </a:solidFill>
+              </a:rPr>
+              <a:t>Track unit production costs across seeds, fertilizer, and labor.</a:t>
+            </a:r>
+          </a:p>
+          <a:p>
+            <a:pPr>
+              <a:spcAft>
+                <a:spcPts val="600"/>
+              </a:spcAft>
+              <a:defRPr b="1" sz="1050">
+                <a:solidFill>
+                  <a:srgbClr val="FFFFFF"/>
+                </a:solidFill>
+              </a:defRPr>
+            </a:pPr>
+            <a:r>
+              <a:t>• Harvest POS Bridge: </a:t>
+            </a:r>
+            <a:r>
+              <a:rPr b="0">
+                <a:solidFill>
+                  <a:srgbClr val="94A3B8"/>
+                </a:solidFill>
+              </a:rPr>
+              <a:t>Automatically convert harvests into POS inventory with auto-generated SKUs and revenue routing.</a:t>
+            </a:r>
+          </a:p>
+        </p:txBody>
+      </p:sp>
+      <p:sp>
+        <p:nvSpPr>
+          <p:cNvPr id="12" name="Rounded Rectangle 11"/>
+          <p:cNvSpPr/>
+          <p:nvPr/>
+        </p:nvSpPr>
+        <p:spPr>
+          <a:xfrm>
+            <a:off x="8906256" y="2560320"/>
+            <a:ext cx="2514600" cy="3749039"/>
+          </a:xfrm>
+          <a:prstGeom prst="roundRect">
+            <a:avLst/>
+          </a:prstGeom>
+          <a:solidFill>
+            <a:srgbClr val="111827"/>
+          </a:solidFill>
+          <a:ln w="19050">
+            <a:solidFill>
+              <a:srgbClr val="10B981"/>
+            </a:solidFill>
+          </a:ln>
+        </p:spPr>
+        <p:style>
+          <a:lnRef idx="1">
+            <a:schemeClr val="accent1"/>
+          </a:lnRef>
+          <a:fillRef idx="3">
+            <a:schemeClr val="accent1"/>
+          </a:fillRef>
+          <a:effectRef idx="2">
+            <a:schemeClr val="accent1"/>
+          </a:effectRef>
+          <a:fontRef idx="minor">
+            <a:schemeClr val="lt1"/>
+          </a:fontRef>
+        </p:style>
+        <p:txBody>
+          <a:bodyPr rtlCol="0" anchor="ctr"/>
+          <a:lstStyle/>
+          <a:p>
+            <a:pPr algn="ctr"/>
+          </a:p>
+        </p:txBody>
+      </p:sp>
+      <p:sp>
+        <p:nvSpPr>
+          <p:cNvPr id="13" name="TextBox 12"/>
+          <p:cNvSpPr txBox="1"/>
+          <p:nvPr/>
+        </p:nvSpPr>
+        <p:spPr>
+          <a:xfrm>
+            <a:off x="9043416" y="2697480"/>
+            <a:ext cx="2240280" cy="3474719"/>
+          </a:xfrm>
+          <a:prstGeom prst="rect">
+            <a:avLst/>
+          </a:prstGeom>
+          <a:noFill/>
+        </p:spPr>
+        <p:txBody>
+          <a:bodyPr wrap="square">
+            <a:spAutoFit/>
+          </a:bodyPr>
+          <a:lstStyle/>
+          <a:p>
+            <a:pPr>
+              <a:spcAft>
+                <a:spcPts val="800"/>
+              </a:spcAft>
+              <a:defRPr sz="1350" b="1">
                 <a:solidFill>
                   <a:srgbClr val="10B981"/>
                 </a:solidFill>
               </a:defRPr>
             </a:pPr>
             <a:r>
-              <a:t>🔒 3. Vault Node (:8000)</a:t>
-            </a:r>
-          </a:p>
-          <a:p>
-            <a:pPr>
-              <a:defRPr sz="1150">
+              <a:t>RO-4: Zero-Exposure Security &amp; Portability</a:t>
+            </a:r>
+          </a:p>
+          <a:p>
+            <a:pPr>
+              <a:spcAft>
+                <a:spcPts val="600"/>
+              </a:spcAft>
+              <a:defRPr b="1" sz="1050">
+                <a:solidFill>
+                  <a:srgbClr val="FFFFFF"/>
+                </a:solidFill>
+              </a:defRPr>
+            </a:pPr>
+            <a:r>
+              <a:t>• RAM Master Keys: </a:t>
+            </a:r>
+            <a:r>
+              <a:rPr b="0">
                 <a:solidFill>
                   <a:srgbClr val="94A3B8"/>
                 </a:solidFill>
-              </a:defRPr>
-            </a:pPr>
-            <a:r>
-              <a:t>Cryptographic coordinator &amp; extensible multi-currency tri-ledger database.</a:t>
-            </a:r>
-            <a:br/>
-            <a:br/>
-            <a:r>
-              <a:t>• Scrypt KDF + TOTP Step-Up MFA authentication.</a:t>
-            </a:r>
-            <a:br/>
-            <a:r>
-              <a:t>• SQLite WAL concurrency with BEGIN IMMEDIATE transaction isolation.</a:t>
-            </a:r>
-            <a:br/>
-            <a:r>
-              <a:t>• Multi-Currency settlement: USD, ZAR, Zimbabwe Gold (ZiG / ZWG).</a:t>
-            </a:r>
-            <a:br/>
-            <a:r>
-              <a:t>• Self-Replicating Node Generator (node_generator.py) for new edge stores.</a:t>
+              </a:rPr>
+              <a:t>Derive ephemeral AES-256-GCM encryption keys in memory via Scrypt KDF.</a:t>
+            </a:r>
+          </a:p>
+          <a:p>
+            <a:pPr>
+              <a:spcAft>
+                <a:spcPts val="600"/>
+              </a:spcAft>
+              <a:defRPr b="1" sz="1050">
+                <a:solidFill>
+                  <a:srgbClr val="FFFFFF"/>
+                </a:solidFill>
+              </a:defRPr>
+            </a:pPr>
+            <a:r>
+              <a:t>• Tamper-Proof Audit: </a:t>
+            </a:r>
+            <a:r>
+              <a:rPr b="0">
+                <a:solidFill>
+                  <a:srgbClr val="94A3B8"/>
+                </a:solidFill>
+              </a:rPr>
+              <a:t>Enforce mathematically chained SHA-256 audit trails.</a:t>
+            </a:r>
+          </a:p>
+          <a:p>
+            <a:pPr>
+              <a:spcAft>
+                <a:spcPts val="600"/>
+              </a:spcAft>
+              <a:defRPr b="1" sz="1050">
+                <a:solidFill>
+                  <a:srgbClr val="FFFFFF"/>
+                </a:solidFill>
+              </a:defRPr>
+            </a:pPr>
+            <a:r>
+              <a:t>• Self-Replicating Nodes: </a:t>
+            </a:r>
+            <a:r>
+              <a:rPr b="0">
+                <a:solidFill>
+                  <a:srgbClr val="94A3B8"/>
+                </a:solidFill>
+              </a:rPr>
+              <a:t>Implement one-click portable node generation (node_generator.py) with zero database exposure.</a:t>
             </a:r>
           </a:p>
         </p:txBody>
@@ -4674,14 +5929,14 @@
           <a:lstStyle/>
           <a:p>
             <a:pPr>
-              <a:defRPr sz="2400" b="1">
+              <a:defRPr sz="2300" b="1">
                 <a:solidFill>
                   <a:srgbClr val="FFFFFF"/>
                 </a:solidFill>
               </a:defRPr>
             </a:pPr>
             <a:r>
-              <a:t>Dynamic Value Systems: Continuous Algorithmic Pricing &amp; Multi-Tender Settlement</a:t>
+              <a:t>Tri-Node Sovereign Architecture: Modular &amp; Composable</a:t>
             </a:r>
           </a:p>
         </p:txBody>
@@ -4695,7 +5950,7 @@
         <p:spPr>
           <a:xfrm>
             <a:off x="731520" y="1463040"/>
-            <a:ext cx="5120640" cy="4754880"/>
+            <a:ext cx="3328416" cy="4663440"/>
           </a:xfrm>
           <a:prstGeom prst="roundRect">
             <a:avLst/>
@@ -4705,7 +5960,7 @@
           </a:solidFill>
           <a:ln w="19050">
             <a:solidFill>
-              <a:srgbClr val="1F2937"/>
+              <a:srgbClr val="00E5FF"/>
             </a:solidFill>
           </a:ln>
         </p:spPr>
@@ -4739,8 +5994,8 @@
         </p:nvSpPr>
         <p:spPr>
           <a:xfrm>
-            <a:off x="1005840" y="1645920"/>
-            <a:ext cx="4572000" cy="4297680"/>
+            <a:off x="914400" y="1645920"/>
+            <a:ext cx="2962656" cy="4297680"/>
           </a:xfrm>
           <a:prstGeom prst="rect">
             <a:avLst/>
@@ -4757,48 +6012,43 @@
               <a:spcAft>
                 <a:spcPts val="1000"/>
               </a:spcAft>
-              <a:defRPr sz="1700" b="1">
+              <a:defRPr sz="1600" b="1">
                 <a:solidFill>
                   <a:srgbClr val="00E5FF"/>
                 </a:solidFill>
               </a:defRPr>
             </a:pPr>
             <a:r>
-              <a:t>📉 Continuous Exponential Price Decay</a:t>
-            </a:r>
-          </a:p>
-          <a:p>
-            <a:pPr>
-              <a:defRPr sz="1200">
+              <a:t>🖥️ 1. Operator Node (:8000)</a:t>
+            </a:r>
+          </a:p>
+          <a:p>
+            <a:pPr>
+              <a:defRPr sz="1150">
                 <a:solidFill>
                   <a:srgbClr val="94A3B8"/>
                 </a:solidFill>
               </a:defRPr>
             </a:pPr>
             <a:r>
-              <a:t>Perishable goods (fresh produce, milk, baked goods) automatically discount in real time based on shelf life while strictly protecting cost floors:</a:t>
+              <a:t>Zero-installation VisionPro Dark Glass Web Client executing in any modern browser.</a:t>
             </a:r>
             <a:br/>
             <a:br/>
             <a:r>
-              <a:t>P(t) = P_cost + (P_base - P_cost) * e^(-λ t)</a:t>
+              <a:t>• Dynamic real-time touch POS register.</a:t>
             </a:r>
             <a:br/>
             <a:r>
-              <a:t>where λ = ln(2) / T_half_life</a:t>
+              <a:t>• Organic concentric glowing avatar profiles with client-side image compression.</a:t>
             </a:r>
             <a:br/>
+            <a:r>
+              <a:t>• Condition-gated progressive disclosure (Store Setup -&gt; POS -&gt; Marketplace).</a:t>
+            </a:r>
             <a:br/>
             <a:r>
-              <a:t>• Eliminates food spoilage &amp; waste before expiration.</a:t>
-            </a:r>
-            <a:br/>
-            <a:r>
-              <a:t>• Maximizes inventory liquidation velocity.</a:t>
-            </a:r>
-            <a:br/>
-            <a:r>
-              <a:t>• Completely autonomous—no manual relabeling required.</a:t>
+              <a:t>• Digital Receipt Vault &amp; QR scanner.</a:t>
             </a:r>
           </a:p>
         </p:txBody>
@@ -4811,8 +6061,8 @@
         </p:nvSpPr>
         <p:spPr>
           <a:xfrm>
-            <a:off x="6309360" y="1463040"/>
-            <a:ext cx="5120640" cy="4754880"/>
+            <a:off x="4425696" y="1463040"/>
+            <a:ext cx="3328416" cy="4663440"/>
           </a:xfrm>
           <a:prstGeom prst="roundRect">
             <a:avLst/>
@@ -4822,7 +6072,7 @@
           </a:solidFill>
           <a:ln w="19050">
             <a:solidFill>
-              <a:srgbClr val="1F2937"/>
+              <a:srgbClr val="7C4DFF"/>
             </a:solidFill>
           </a:ln>
         </p:spPr>
@@ -4856,8 +6106,8 @@
         </p:nvSpPr>
         <p:spPr>
           <a:xfrm>
-            <a:off x="6583680" y="1645920"/>
-            <a:ext cx="4572000" cy="4297680"/>
+            <a:off x="4608576" y="1645920"/>
+            <a:ext cx="2962656" cy="4297680"/>
           </a:xfrm>
           <a:prstGeom prst="rect">
             <a:avLst/>
@@ -4874,44 +6124,155 @@
               <a:spcAft>
                 <a:spcPts val="1000"/>
               </a:spcAft>
-              <a:defRPr sz="1700" b="1">
-                <a:solidFill>
-                  <a:srgbClr val="F59E0B"/>
-                </a:solidFill>
-              </a:defRPr>
-            </a:pPr>
-            <a:r>
-              <a:t>💱 Tri-Currency Split Tender &amp; Offline Vouchers</a:t>
-            </a:r>
-          </a:p>
-          <a:p>
-            <a:pPr>
-              <a:defRPr sz="1200">
+              <a:defRPr sz="1600" b="1">
+                <a:solidFill>
+                  <a:srgbClr val="7C4DFF"/>
+                </a:solidFill>
+              </a:defRPr>
+            </a:pPr>
+            <a:r>
+              <a:t>📡 2. Data Node (:8002)</a:t>
+            </a:r>
+          </a:p>
+          <a:p>
+            <a:pPr>
+              <a:defRPr sz="1150">
                 <a:solidFill>
                   <a:srgbClr val="94A3B8"/>
                 </a:solidFill>
               </a:defRPr>
             </a:pPr>
             <a:r>
-              <a:t>Real-time mixed tender point-of-sale checkout:</a:t>
+              <a:t>Standalone storage, multicast peer discovery, and global currency collector.</a:t>
             </a:r>
             <a:br/>
             <a:br/>
             <a:r>
-              <a:t>V_paid = T_USD + (T_ZAR / rate_ZAR) + (T_ZWG / rate_ZWG)</a:t>
+              <a:t>• UDP Multicast Heartbeats (224.0.0.251:8001) for zero-config local mesh discovery.</a:t>
+            </a:r>
+            <a:br/>
+            <a:r>
+              <a:t>• 170+ ISO Fiat &amp; 50+ Crypto Currency Catalog with air-gapped fallback.</a:t>
+            </a:r>
+            <a:br/>
+            <a:r>
+              <a:t>• Encrypted Key-Value store with AES-256-GCM data-at-rest protection.</a:t>
+            </a:r>
+            <a:br/>
+            <a:r>
+              <a:t>• Remote lifecycle &amp; maintenance controls.</a:t>
+            </a:r>
+          </a:p>
+        </p:txBody>
+      </p:sp>
+      <p:sp>
+        <p:nvSpPr>
+          <p:cNvPr id="8" name="Rounded Rectangle 7"/>
+          <p:cNvSpPr/>
+          <p:nvPr/>
+        </p:nvSpPr>
+        <p:spPr>
+          <a:xfrm>
+            <a:off x="8119872" y="1463040"/>
+            <a:ext cx="3328416" cy="4663440"/>
+          </a:xfrm>
+          <a:prstGeom prst="roundRect">
+            <a:avLst/>
+          </a:prstGeom>
+          <a:solidFill>
+            <a:srgbClr val="111827"/>
+          </a:solidFill>
+          <a:ln w="19050">
+            <a:solidFill>
+              <a:srgbClr val="10B981"/>
+            </a:solidFill>
+          </a:ln>
+        </p:spPr>
+        <p:style>
+          <a:lnRef idx="1">
+            <a:schemeClr val="accent1"/>
+          </a:lnRef>
+          <a:fillRef idx="3">
+            <a:schemeClr val="accent1"/>
+          </a:fillRef>
+          <a:effectRef idx="2">
+            <a:schemeClr val="accent1"/>
+          </a:effectRef>
+          <a:fontRef idx="minor">
+            <a:schemeClr val="lt1"/>
+          </a:fontRef>
+        </p:style>
+        <p:txBody>
+          <a:bodyPr rtlCol="0" anchor="ctr"/>
+          <a:lstStyle/>
+          <a:p>
+            <a:pPr algn="ctr"/>
+          </a:p>
+        </p:txBody>
+      </p:sp>
+      <p:sp>
+        <p:nvSpPr>
+          <p:cNvPr id="9" name="TextBox 8"/>
+          <p:cNvSpPr txBox="1"/>
+          <p:nvPr/>
+        </p:nvSpPr>
+        <p:spPr>
+          <a:xfrm>
+            <a:off x="8302752" y="1645920"/>
+            <a:ext cx="2962656" cy="4297680"/>
+          </a:xfrm>
+          <a:prstGeom prst="rect">
+            <a:avLst/>
+          </a:prstGeom>
+          <a:noFill/>
+        </p:spPr>
+        <p:txBody>
+          <a:bodyPr wrap="square">
+            <a:spAutoFit/>
+          </a:bodyPr>
+          <a:lstStyle/>
+          <a:p>
+            <a:pPr>
+              <a:spcAft>
+                <a:spcPts val="1000"/>
+              </a:spcAft>
+              <a:defRPr sz="1600" b="1">
+                <a:solidFill>
+                  <a:srgbClr val="10B981"/>
+                </a:solidFill>
+              </a:defRPr>
+            </a:pPr>
+            <a:r>
+              <a:t>🔒 3. Vault Node (:8000)</a:t>
+            </a:r>
+          </a:p>
+          <a:p>
+            <a:pPr>
+              <a:defRPr sz="1150">
+                <a:solidFill>
+                  <a:srgbClr val="94A3B8"/>
+                </a:solidFill>
+              </a:defRPr>
+            </a:pPr>
+            <a:r>
+              <a:t>Cryptographic coordinator &amp; extensible multi-currency tri-ledger database.</a:t>
             </a:r>
             <a:br/>
             <a:br/>
             <a:r>
-              <a:t>• Solves Change Shortages: Mint cryptographic QR change vouchers when physical coins are unavailable.</a:t>
+              <a:t>• Scrypt KDF + TOTP Step-Up MFA authentication.</a:t>
             </a:r>
             <a:br/>
             <a:r>
-              <a:t>• Air-Gapped Verification: HMAC-SHA256 digital signatures prevent counterfeit vouchers and double-spends offline.</a:t>
+              <a:t>• SQLite WAL concurrency with BEGIN IMMEDIATE transaction isolation.</a:t>
             </a:r>
             <a:br/>
             <a:r>
-              <a:t>• Instant Wallet Redemption: Customers can deposit voucher change into digital banking wallets with zero internet.</a:t>
+              <a:t>• Multi-Currency settlement: USD, ZAR, Zimbabwe Gold (ZiG / ZWG).</a:t>
+            </a:r>
+            <a:br/>
+            <a:r>
+              <a:t>• Self-Replicating Node Generator (node_generator.py) for new edge stores.</a:t>
             </a:r>
           </a:p>
         </p:txBody>
@@ -5000,14 +6361,14 @@
           <a:lstStyle/>
           <a:p>
             <a:pPr>
-              <a:defRPr sz="2400" b="1">
+              <a:defRPr sz="2300" b="1">
                 <a:solidFill>
                   <a:srgbClr val="FFFFFF"/>
                 </a:solidFill>
               </a:defRPr>
             </a:pPr>
             <a:r>
-              <a:t>Precision Agriculture: Autonomous Farm-to-Fork Value Chains</a:t>
+              <a:t>System Architectural Block Diagram &amp; Inter-Node Protocols</a:t>
             </a:r>
           </a:p>
         </p:txBody>
@@ -5020,8 +6381,8 @@
         </p:nvSpPr>
         <p:spPr>
           <a:xfrm>
-            <a:off x="731520" y="1463040"/>
-            <a:ext cx="2468880" cy="4663440"/>
+            <a:off x="731520" y="1371600"/>
+            <a:ext cx="3291840" cy="4206240"/>
           </a:xfrm>
           <a:prstGeom prst="roundRect">
             <a:avLst/>
@@ -5031,7 +6392,7 @@
           </a:solidFill>
           <a:ln w="19050">
             <a:solidFill>
-              <a:srgbClr val="1F2937"/>
+              <a:srgbClr val="00E5FF"/>
             </a:solidFill>
           </a:ln>
         </p:spPr>
@@ -5065,8 +6426,8 @@
         </p:nvSpPr>
         <p:spPr>
           <a:xfrm>
-            <a:off x="868680" y="1645920"/>
-            <a:ext cx="2194560" cy="4297680"/>
+            <a:off x="868680" y="1508760"/>
+            <a:ext cx="3017520" cy="3931920"/>
           </a:xfrm>
           <a:prstGeom prst="rect">
             <a:avLst/>
@@ -5081,28 +6442,158 @@
           <a:p>
             <a:pPr>
               <a:spcAft>
-                <a:spcPts val="1200"/>
+                <a:spcPts val="800"/>
               </a:spcAft>
-              <a:defRPr sz="1500" b="1">
+              <a:defRPr sz="1350" b="1">
                 <a:solidFill>
                   <a:srgbClr val="00E5FF"/>
                 </a:solidFill>
               </a:defRPr>
             </a:pPr>
             <a:r>
-              <a:t>🌱 Step 1: Fields &amp; Plots</a:t>
-            </a:r>
-          </a:p>
-          <a:p>
-            <a:pPr>
-              <a:defRPr sz="1150">
+              <a:t>🖥️ OPERATOR NODE (:8000)</a:t>
+            </a:r>
+            <a:br/>
+            <a:r>
+              <a:t>VisionPro Glass Frontend</a:t>
+            </a:r>
+          </a:p>
+          <a:p>
+            <a:pPr>
+              <a:spcAft>
+                <a:spcPts val="300"/>
+              </a:spcAft>
+              <a:defRPr b="1" sz="1000">
+                <a:solidFill>
+                  <a:srgbClr val="FFFFFF"/>
+                </a:solidFill>
+              </a:defRPr>
+            </a:pPr>
+            <a:r>
+              <a:t>• VisionPro SPA Client: </a:t>
+            </a:r>
+            <a:r>
+              <a:rPr b="0">
                 <a:solidFill>
                   <a:srgbClr val="94A3B8"/>
                 </a:solidFill>
-              </a:defRPr>
-            </a:pPr>
-            <a:r>
-              <a:t>Geospatial soil mapping, irrigation tracking, and real-time Bulawayo climate sensor integration. Track hectare yields directly on edge devices.</a:t>
+              </a:rPr>
+              <a:t>Vanilla ES6+, glassmorphism CSS, hardware canvas.</a:t>
+            </a:r>
+          </a:p>
+          <a:p>
+            <a:pPr>
+              <a:spcAft>
+                <a:spcPts val="300"/>
+              </a:spcAft>
+              <a:defRPr b="1" sz="1000">
+                <a:solidFill>
+                  <a:srgbClr val="FFFFFF"/>
+                </a:solidFill>
+              </a:defRPr>
+            </a:pPr>
+            <a:r>
+              <a:t>• Touch POS &amp; Dynamic Catalog: </a:t>
+            </a:r>
+            <a:r>
+              <a:rPr b="0">
+                <a:solidFill>
+                  <a:srgbClr val="94A3B8"/>
+                </a:solidFill>
+              </a:rPr>
+              <a:t>Real-time pricing, search, quick cart.</a:t>
+            </a:r>
+          </a:p>
+          <a:p>
+            <a:pPr>
+              <a:spcAft>
+                <a:spcPts val="300"/>
+              </a:spcAft>
+              <a:defRPr b="1" sz="1000">
+                <a:solidFill>
+                  <a:srgbClr val="FFFFFF"/>
+                </a:solidFill>
+              </a:defRPr>
+            </a:pPr>
+            <a:r>
+              <a:t>• Dynamic Subnav Controllers: </a:t>
+            </a:r>
+            <a:r>
+              <a:rPr b="0">
+                <a:solidFill>
+                  <a:srgbClr val="94A3B8"/>
+                </a:solidFill>
+              </a:rPr>
+              <a:t>Precondition state evaluation (N_biz, N_prod).</a:t>
+            </a:r>
+          </a:p>
+          <a:p>
+            <a:pPr>
+              <a:spcAft>
+                <a:spcPts val="300"/>
+              </a:spcAft>
+              <a:defRPr b="1" sz="1000">
+                <a:solidFill>
+                  <a:srgbClr val="FFFFFF"/>
+                </a:solidFill>
+              </a:defRPr>
+            </a:pPr>
+            <a:r>
+              <a:t>• Organic Avatar Studio: </a:t>
+            </a:r>
+            <a:r>
+              <a:rPr b="0">
+                <a:solidFill>
+                  <a:srgbClr val="94A3B8"/>
+                </a:solidFill>
+              </a:rPr>
+              <a:t>createImageBitmap GPU scaling &amp; live preview.</a:t>
+            </a:r>
+          </a:p>
+          <a:p>
+            <a:pPr>
+              <a:spcAft>
+                <a:spcPts val="300"/>
+              </a:spcAft>
+              <a:defRPr b="1" sz="1000">
+                <a:solidFill>
+                  <a:srgbClr val="FFFFFF"/>
+                </a:solidFill>
+              </a:defRPr>
+            </a:pPr>
+            <a:r>
+              <a:t>• Customer Receipt Vault: </a:t>
+            </a:r>
+            <a:r>
+              <a:rPr b="0">
+                <a:solidFill>
+                  <a:srgbClr val="94A3B8"/>
+                </a:solidFill>
+              </a:rPr>
+              <a:t>Encrypted digital receipt lookup &amp; QR scan.</a:t>
+            </a:r>
+          </a:p>
+          <a:p>
+            <a:pPr>
+              <a:spcAft>
+                <a:spcPts val="300"/>
+              </a:spcAft>
+              <a:defRPr b="1" sz="1000">
+                <a:solidFill>
+                  <a:srgbClr val="FFFFFF"/>
+                </a:solidFill>
+              </a:defRPr>
+            </a:pPr>
+            <a:r>
+              <a:t>• Offline QR Voucher Terminal: </a:t>
+            </a:r>
+            <a:r>
+              <a:rPr b="0">
+                <a:solidFill>
+                  <a:srgbClr val="94A3B8"/>
+                </a:solidFill>
+              </a:rPr>
+              <a:t>Camera scan &amp; instant wallet redemption.</a:t>
             </a:r>
           </a:p>
         </p:txBody>
@@ -5115,8 +6606,8 @@
         </p:nvSpPr>
         <p:spPr>
           <a:xfrm>
-            <a:off x="3429000" y="1463040"/>
-            <a:ext cx="2468880" cy="4663440"/>
+            <a:off x="4434840" y="1371600"/>
+            <a:ext cx="3291840" cy="4206240"/>
           </a:xfrm>
           <a:prstGeom prst="roundRect">
             <a:avLst/>
@@ -5126,7 +6617,7 @@
           </a:solidFill>
           <a:ln w="19050">
             <a:solidFill>
-              <a:srgbClr val="1F2937"/>
+              <a:srgbClr val="10B981"/>
             </a:solidFill>
           </a:ln>
         </p:spPr>
@@ -5160,8 +6651,8 @@
         </p:nvSpPr>
         <p:spPr>
           <a:xfrm>
-            <a:off x="3566160" y="1645920"/>
-            <a:ext cx="2194560" cy="4297680"/>
+            <a:off x="4572000" y="1508760"/>
+            <a:ext cx="3017520" cy="3931920"/>
           </a:xfrm>
           <a:prstGeom prst="rect">
             <a:avLst/>
@@ -5176,28 +6667,181 @@
           <a:p>
             <a:pPr>
               <a:spcAft>
-                <a:spcPts val="1200"/>
+                <a:spcPts val="800"/>
               </a:spcAft>
-              <a:defRPr sz="1500" b="1">
-                <a:solidFill>
-                  <a:srgbClr val="7C4DFF"/>
-                </a:solidFill>
-              </a:defRPr>
-            </a:pPr>
-            <a:r>
-              <a:t>🚜 Step 2: Crop Plantings</a:t>
-            </a:r>
-          </a:p>
-          <a:p>
-            <a:pPr>
-              <a:defRPr sz="1150">
+              <a:defRPr sz="1350" b="1">
+                <a:solidFill>
+                  <a:srgbClr val="10B981"/>
+                </a:solidFill>
+              </a:defRPr>
+            </a:pPr>
+            <a:r>
+              <a:t>🔒 VAULT NODE (:8000)</a:t>
+            </a:r>
+            <a:br/>
+            <a:r>
+              <a:t>FastAPI &amp; Multi-Ledger Core</a:t>
+            </a:r>
+          </a:p>
+          <a:p>
+            <a:pPr>
+              <a:spcAft>
+                <a:spcPts val="300"/>
+              </a:spcAft>
+              <a:defRPr b="1" sz="1000">
+                <a:solidFill>
+                  <a:srgbClr val="FFFFFF"/>
+                </a:solidFill>
+              </a:defRPr>
+            </a:pPr>
+            <a:r>
+              <a:t>• FastAPI REST Engine: </a:t>
+            </a:r>
+            <a:r>
+              <a:rPr b="0">
                 <a:solidFill>
                   <a:srgbClr val="94A3B8"/>
                 </a:solidFill>
-              </a:defRPr>
-            </a:pPr>
-            <a:r>
-              <a:t>Structured lifecycle plans from germination to harvest. Fertilizer, labor, and fuel input ledgering linked to field plots.</a:t>
+              </a:rPr>
+              <a:t>Asynchronous endpoints, zero-cache headers, CSP.</a:t>
+            </a:r>
+          </a:p>
+          <a:p>
+            <a:pPr>
+              <a:spcAft>
+                <a:spcPts val="300"/>
+              </a:spcAft>
+              <a:defRPr b="1" sz="1000">
+                <a:solidFill>
+                  <a:srgbClr val="FFFFFF"/>
+                </a:solidFill>
+              </a:defRPr>
+            </a:pPr>
+            <a:r>
+              <a:t>• Scrypt &amp; TOTP Auth Engine: </a:t>
+            </a:r>
+            <a:r>
+              <a:rPr b="0">
+                <a:solidFill>
+                  <a:srgbClr val="94A3B8"/>
+                </a:solidFill>
+              </a:rPr>
+              <a:t>Password hashing, session token cookies, tarpit.</a:t>
+            </a:r>
+          </a:p>
+          <a:p>
+            <a:pPr>
+              <a:spcAft>
+                <a:spcPts val="300"/>
+              </a:spcAft>
+              <a:defRPr b="1" sz="1000">
+                <a:solidFill>
+                  <a:srgbClr val="FFFFFF"/>
+                </a:solidFill>
+              </a:defRPr>
+            </a:pPr>
+            <a:r>
+              <a:t>• SQLite WAL Tri-Ledger: </a:t>
+            </a:r>
+            <a:r>
+              <a:rPr b="0">
+                <a:solidFill>
+                  <a:srgbClr val="94A3B8"/>
+                </a:solidFill>
+              </a:rPr>
+              <a:t>ACID locks (BEGIN IMMEDIATE), B-tree indexes.</a:t>
+            </a:r>
+          </a:p>
+          <a:p>
+            <a:pPr>
+              <a:spcAft>
+                <a:spcPts val="300"/>
+              </a:spcAft>
+              <a:defRPr b="1" sz="1000">
+                <a:solidFill>
+                  <a:srgbClr val="FFFFFF"/>
+                </a:solidFill>
+              </a:defRPr>
+            </a:pPr>
+            <a:r>
+              <a:t>• Dynamic Pricing Engine: </a:t>
+            </a:r>
+            <a:r>
+              <a:rPr b="0">
+                <a:solidFill>
+                  <a:srgbClr val="94A3B8"/>
+                </a:solidFill>
+              </a:rPr>
+              <a:t>Continuous exponential decay &amp; cost-floor bounds.</a:t>
+            </a:r>
+          </a:p>
+          <a:p>
+            <a:pPr>
+              <a:spcAft>
+                <a:spcPts val="300"/>
+              </a:spcAft>
+              <a:defRPr b="1" sz="1000">
+                <a:solidFill>
+                  <a:srgbClr val="FFFFFF"/>
+                </a:solidFill>
+              </a:defRPr>
+            </a:pPr>
+            <a:r>
+              <a:t>• Multi-Tender Engine: </a:t>
+            </a:r>
+            <a:r>
+              <a:rPr b="0">
+                <a:solidFill>
+                  <a:srgbClr val="94A3B8"/>
+                </a:solidFill>
+              </a:rPr>
+              <a:t>Tri-currency basket split (USD, ZAR, ZiG).</a:t>
+            </a:r>
+          </a:p>
+          <a:p>
+            <a:pPr>
+              <a:spcAft>
+                <a:spcPts val="300"/>
+              </a:spcAft>
+              <a:defRPr b="1" sz="1000">
+                <a:solidFill>
+                  <a:srgbClr val="FFFFFF"/>
+                </a:solidFill>
+              </a:defRPr>
+            </a:pPr>
+            <a:r>
+              <a:t>• Offline Voucher Signer: </a:t>
+            </a:r>
+            <a:r>
+              <a:rPr b="0">
+                <a:solidFill>
+                  <a:srgbClr val="94A3B8"/>
+                </a:solidFill>
+              </a:rPr>
+              <a:t>HMAC-SHA256 digital signature minting.</a:t>
+            </a:r>
+          </a:p>
+          <a:p>
+            <a:pPr>
+              <a:spcAft>
+                <a:spcPts val="300"/>
+              </a:spcAft>
+              <a:defRPr b="1" sz="1000">
+                <a:solidFill>
+                  <a:srgbClr val="FFFFFF"/>
+                </a:solidFill>
+              </a:defRPr>
+            </a:pPr>
+            <a:r>
+              <a:t>• Node Generator Hub: </a:t>
+            </a:r>
+            <a:r>
+              <a:rPr b="0">
+                <a:solidFill>
+                  <a:srgbClr val="94A3B8"/>
+                </a:solidFill>
+              </a:rPr>
+              <a:t>node_generator.py self-replicating engine.</a:t>
             </a:r>
           </a:p>
         </p:txBody>
@@ -5210,8 +6854,8 @@
         </p:nvSpPr>
         <p:spPr>
           <a:xfrm>
-            <a:off x="6126480" y="1463040"/>
-            <a:ext cx="2468880" cy="4663440"/>
+            <a:off x="8138160" y="1371600"/>
+            <a:ext cx="3291840" cy="4206240"/>
           </a:xfrm>
           <a:prstGeom prst="roundRect">
             <a:avLst/>
@@ -5221,7 +6865,7 @@
           </a:solidFill>
           <a:ln w="19050">
             <a:solidFill>
-              <a:srgbClr val="1F2937"/>
+              <a:srgbClr val="7C4DFF"/>
             </a:solidFill>
           </a:ln>
         </p:spPr>
@@ -5255,8 +6899,8 @@
         </p:nvSpPr>
         <p:spPr>
           <a:xfrm>
-            <a:off x="6263640" y="1645920"/>
-            <a:ext cx="2194560" cy="4297680"/>
+            <a:off x="8275320" y="1508760"/>
+            <a:ext cx="3017520" cy="3931920"/>
           </a:xfrm>
           <a:prstGeom prst="rect">
             <a:avLst/>
@@ -5271,28 +6915,158 @@
           <a:p>
             <a:pPr>
               <a:spcAft>
-                <a:spcPts val="1200"/>
+                <a:spcPts val="800"/>
               </a:spcAft>
-              <a:defRPr sz="1500" b="1">
-                <a:solidFill>
-                  <a:srgbClr val="F59E0B"/>
-                </a:solidFill>
-              </a:defRPr>
-            </a:pPr>
-            <a:r>
-              <a:t>📊 Step 3: Cost &amp; Price Calc</a:t>
-            </a:r>
-          </a:p>
-          <a:p>
-            <a:pPr>
-              <a:defRPr sz="1150">
+              <a:defRPr sz="1350" b="1">
+                <a:solidFill>
+                  <a:srgbClr val="7C4DFF"/>
+                </a:solidFill>
+              </a:defRPr>
+            </a:pPr>
+            <a:r>
+              <a:t>📡 DATA NODE (:8002)</a:t>
+            </a:r>
+            <a:br/>
+            <a:r>
+              <a:t>Mesh Discovery &amp; Currency Vault</a:t>
+            </a:r>
+          </a:p>
+          <a:p>
+            <a:pPr>
+              <a:spcAft>
+                <a:spcPts val="300"/>
+              </a:spcAft>
+              <a:defRPr b="1" sz="1000">
+                <a:solidFill>
+                  <a:srgbClr val="FFFFFF"/>
+                </a:solidFill>
+              </a:defRPr>
+            </a:pPr>
+            <a:r>
+              <a:t>• UDP Multicast Beacon: </a:t>
+            </a:r>
+            <a:r>
+              <a:rPr b="0">
                 <a:solidFill>
                   <a:srgbClr val="94A3B8"/>
                 </a:solidFill>
-              </a:defRPr>
-            </a:pPr>
-            <a:r>
-              <a:t>Automated unit cost calculation factoring seeds, labor, water, and margin targets. Calculates recommended base selling price automatically.</a:t>
+              </a:rPr>
+              <a:t>224.0.0.251:8001 heartbeat broadcast every 5s.</a:t>
+            </a:r>
+          </a:p>
+          <a:p>
+            <a:pPr>
+              <a:spcAft>
+                <a:spcPts val="300"/>
+              </a:spcAft>
+              <a:defRPr b="1" sz="1000">
+                <a:solidFill>
+                  <a:srgbClr val="FFFFFF"/>
+                </a:solidFill>
+              </a:defRPr>
+            </a:pPr>
+            <a:r>
+              <a:t>• World Currency Registry: </a:t>
+            </a:r>
+            <a:r>
+              <a:rPr b="0">
+                <a:solidFill>
+                  <a:srgbClr val="94A3B8"/>
+                </a:solidFill>
+              </a:rPr>
+              <a:t>170+ ISO fiats + 50+ cryptos with offline cache.</a:t>
+            </a:r>
+          </a:p>
+          <a:p>
+            <a:pPr>
+              <a:spcAft>
+                <a:spcPts val="300"/>
+              </a:spcAft>
+              <a:defRPr b="1" sz="1000">
+                <a:solidFill>
+                  <a:srgbClr val="FFFFFF"/>
+                </a:solidFill>
+              </a:defRPr>
+            </a:pPr>
+            <a:r>
+              <a:t>• Collision Validator: </a:t>
+            </a:r>
+            <a:r>
+              <a:rPr b="0">
+                <a:solidFill>
+                  <a:srgbClr val="94A3B8"/>
+                </a:solidFill>
+              </a:rPr>
+              <a:t>Multi-tier symbol &amp; namespace protection.</a:t>
+            </a:r>
+          </a:p>
+          <a:p>
+            <a:pPr>
+              <a:spcAft>
+                <a:spcPts val="300"/>
+              </a:spcAft>
+              <a:defRPr b="1" sz="1000">
+                <a:solidFill>
+                  <a:srgbClr val="FFFFFF"/>
+                </a:solidFill>
+              </a:defRPr>
+            </a:pPr>
+            <a:r>
+              <a:t>• Encrypted KV Store: </a:t>
+            </a:r>
+            <a:r>
+              <a:rPr b="0">
+                <a:solidFill>
+                  <a:srgbClr val="94A3B8"/>
+                </a:solidFill>
+              </a:rPr>
+              <a:t>AES-256-GCM encrypted persistence at rest.</a:t>
+            </a:r>
+          </a:p>
+          <a:p>
+            <a:pPr>
+              <a:spcAft>
+                <a:spcPts val="300"/>
+              </a:spcAft>
+              <a:defRPr b="1" sz="1000">
+                <a:solidFill>
+                  <a:srgbClr val="FFFFFF"/>
+                </a:solidFill>
+              </a:defRPr>
+            </a:pPr>
+            <a:r>
+              <a:t>• Lifecycle API: </a:t>
+            </a:r>
+            <a:r>
+              <a:rPr b="0">
+                <a:solidFill>
+                  <a:srgbClr val="94A3B8"/>
+                </a:solidFill>
+              </a:rPr>
+              <a:t>Remote activate/deactivate &amp; maintenance mode.</a:t>
+            </a:r>
+          </a:p>
+          <a:p>
+            <a:pPr>
+              <a:spcAft>
+                <a:spcPts val="300"/>
+              </a:spcAft>
+              <a:defRPr b="1" sz="1000">
+                <a:solidFill>
+                  <a:srgbClr val="FFFFFF"/>
+                </a:solidFill>
+              </a:defRPr>
+            </a:pPr>
+            <a:r>
+              <a:t>• Telemetry Collector: </a:t>
+            </a:r>
+            <a:r>
+              <a:rPr b="0">
+                <a:solidFill>
+                  <a:srgbClr val="94A3B8"/>
+                </a:solidFill>
+              </a:rPr>
+              <a:t>LWW node position &amp; peer health telemetry.</a:t>
             </a:r>
           </a:p>
         </p:txBody>
@@ -5305,8 +7079,8 @@
         </p:nvSpPr>
         <p:spPr>
           <a:xfrm>
-            <a:off x="8823960" y="1463040"/>
-            <a:ext cx="2468880" cy="4663440"/>
+            <a:off x="731520" y="5669280"/>
+            <a:ext cx="10698480" cy="822960"/>
           </a:xfrm>
           <a:prstGeom prst="roundRect">
             <a:avLst/>
@@ -5316,7 +7090,7 @@
           </a:solidFill>
           <a:ln w="19050">
             <a:solidFill>
-              <a:srgbClr val="1F2937"/>
+              <a:srgbClr val="38BDF8"/>
             </a:solidFill>
           </a:ln>
         </p:spPr>
@@ -5350,8 +7124,8 @@
         </p:nvSpPr>
         <p:spPr>
           <a:xfrm>
-            <a:off x="8961120" y="1645920"/>
-            <a:ext cx="2194560" cy="4297680"/>
+            <a:off x="914400" y="5715000"/>
+            <a:ext cx="10332720" cy="731520"/>
           </a:xfrm>
           <a:prstGeom prst="rect">
             <a:avLst/>
@@ -5365,29 +7139,26 @@
           <a:lstStyle/>
           <a:p>
             <a:pPr>
-              <a:spcAft>
-                <a:spcPts val="1200"/>
-              </a:spcAft>
-              <a:defRPr sz="1500" b="1">
-                <a:solidFill>
-                  <a:srgbClr val="10B981"/>
-                </a:solidFill>
-              </a:defRPr>
-            </a:pPr>
-            <a:r>
-              <a:t>🏪 Step 4: Harvest POS Sync</a:t>
-            </a:r>
-          </a:p>
-          <a:p>
-            <a:pPr>
-              <a:defRPr sz="1150">
+              <a:defRPr sz="1100" b="1">
+                <a:solidFill>
+                  <a:srgbClr val="00E5FF"/>
+                </a:solidFill>
+              </a:defRPr>
+            </a:pPr>
+            <a:r>
+              <a:t>🔗 INTER-NODE PROTOCOLS &amp; DATA PIPELINES</a:t>
+            </a:r>
+          </a:p>
+          <a:p>
+            <a:pPr>
+              <a:defRPr sz="950">
                 <a:solidFill>
                   <a:srgbClr val="94A3B8"/>
                 </a:solidFill>
               </a:defRPr>
             </a:pPr>
             <a:r>
-              <a:t>Harvested crops instantly populate store inventory catalogs. Automated dynamic SKU generation, live stock decrementing, and revenue routing.</a:t>
+              <a:t>① Operator ↔ Vault: JSON REST + HMAC-SHA256 Bearer &amp; HttpOnly Session Cookies  |  ② Vault ↔ Data Node: HTTP Collection Sync &amp; Collision Validation  |  ③ Data Node ↔ Mesh: UDP Multicast (224.0.0.251:8001) Zero-Config Beacon  |  ④ Vault ↔ Edge Device: Scrypt Derived AES-256-GCM Storage</a:t>
             </a:r>
           </a:p>
         </p:txBody>
@@ -5476,14 +7247,14 @@
           <a:lstStyle/>
           <a:p>
             <a:pPr>
-              <a:defRPr sz="2400" b="1">
+              <a:defRPr sz="2300" b="1">
                 <a:solidFill>
                   <a:srgbClr val="FFFFFF"/>
                 </a:solidFill>
               </a:defRPr>
             </a:pPr>
             <a:r>
-              <a:t>Military-Grade Security &amp; Sovereign Zero-Data Exposure</a:t>
+              <a:t>Dynamic Value Systems: Continuous Pricing &amp; Multi-Tender Settlement</a:t>
             </a:r>
           </a:p>
         </p:txBody>
@@ -5507,7 +7278,7 @@
           </a:solidFill>
           <a:ln w="19050">
             <a:solidFill>
-              <a:srgbClr val="10B981"/>
+              <a:srgbClr val="00E5FF"/>
             </a:solidFill>
           </a:ln>
         </p:spPr>
@@ -5561,12 +7332,12 @@
               </a:spcAft>
               <a:defRPr sz="1700" b="1">
                 <a:solidFill>
-                  <a:srgbClr val="10B981"/>
-                </a:solidFill>
-              </a:defRPr>
-            </a:pPr>
-            <a:r>
-              <a:t>🛡️ Cryptographic Primitives &amp; RAM Keys</a:t>
+                  <a:srgbClr val="00E5FF"/>
+                </a:solidFill>
+              </a:defRPr>
+            </a:pPr>
+            <a:r>
+              <a:t>📉 Continuous Exponential Price Decay</a:t>
             </a:r>
           </a:p>
           <a:p>
@@ -5578,24 +7349,29 @@
               </a:defRPr>
             </a:pPr>
             <a:r>
-              <a:t>Zero hardcoded secrets and memory-isolated key derivation:</a:t>
+              <a:t>Perishable goods (fresh produce, milk, baked goods) automatically discount in real time based on shelf life while strictly protecting cost floors:</a:t>
             </a:r>
             <a:br/>
             <a:br/>
             <a:r>
-              <a:t>• AES-256-GCM Authenticated Encryption at rest for customer receipts, visitor registries, and KV data.</a:t>
+              <a:t>P(t) = P_cost + (P_base - P_cost) * e^(-λ t)</a:t>
             </a:r>
             <a:br/>
             <a:r>
-              <a:t>• Scrypt Master Key Derivation (N=32768, r=8, p=1) prioritizing dynamic environment passphrases.</a:t>
+              <a:t>where λ = ln(2) / T_half_life</a:t>
             </a:r>
             <a:br/>
-            <a:r>
-              <a:t>• Tamper-Evident SHA-256 Audit Trails: Chained hash logs where modifying historical entries breaks mathematical verification.</a:t>
-            </a:r>
             <a:br/>
             <a:r>
-              <a:t>• Dynamic Tarpit Lockouts: Exponential rate-limiting defeating brute-force credential attacks.</a:t>
+              <a:t>• Eliminates food spoilage &amp; waste before expiration.</a:t>
+            </a:r>
+            <a:br/>
+            <a:r>
+              <a:t>• Maximizes inventory liquidation velocity.</a:t>
+            </a:r>
+            <a:br/>
+            <a:r>
+              <a:t>• Completely autonomous—no manual relabeling required.</a:t>
             </a:r>
           </a:p>
         </p:txBody>
@@ -5619,7 +7395,7 @@
           </a:solidFill>
           <a:ln w="19050">
             <a:solidFill>
-              <a:srgbClr val="7C4DFF"/>
+              <a:srgbClr val="F59E0B"/>
             </a:solidFill>
           </a:ln>
         </p:spPr>
@@ -5673,12 +7449,12 @@
               </a:spcAft>
               <a:defRPr sz="1700" b="1">
                 <a:solidFill>
-                  <a:srgbClr val="7C4DFF"/>
-                </a:solidFill>
-              </a:defRPr>
-            </a:pPr>
-            <a:r>
-              <a:t>📦 Self-Replicating Sovereign Nodes</a:t>
+                  <a:srgbClr val="F59E0B"/>
+                </a:solidFill>
+              </a:defRPr>
+            </a:pPr>
+            <a:r>
+              <a:t>💱 Tri-Currency Split Tender &amp; Offline Vouchers</a:t>
             </a:r>
           </a:p>
           <a:p>
@@ -5690,20 +7466,25 @@
               </a:defRPr>
             </a:pPr>
             <a:r>
-              <a:t>Portable node replication and total Git database isolation:</a:t>
+              <a:t>Real-time mixed tender point-of-sale checkout:</a:t>
             </a:r>
             <a:br/>
             <a:br/>
             <a:r>
-              <a:t>• Git Database Isolation: All runtime databases (*.db, *.db-wal) are permanently excluded from git sync, guaranteeing zero sensitive customer data exposure on public repositories.</a:t>
+              <a:t>V_paid = T_USD + (T_ZAR / rate_ZAR) + (T_ZWG / rate_ZWG)</a:t>
             </a:r>
             <a:br/>
-            <a:r>
-              <a:t>• Autonomous Node Generator (node_generator.py): Export standalone portable business nodes (e.g. Khumalo Millers, Matopos Dairy) with 1 click.</a:t>
-            </a:r>
             <a:br/>
             <a:r>
-              <a:t>• Zero-Config Bootstrapper (start.py): Auto-installs virtual environments, resolves missing dependencies, and spins up local services.</a:t>
+              <a:t>• Solves Change Shortages: Mint cryptographic QR change vouchers when physical coins are unavailable.</a:t>
+            </a:r>
+            <a:br/>
+            <a:r>
+              <a:t>• Air-Gapped Verification: HMAC-SHA256 digital signatures prevent counterfeit vouchers and double-spends offline.</a:t>
+            </a:r>
+            <a:br/>
+            <a:r>
+              <a:t>• Instant Wallet Redemption: Customers can deposit voucher change into digital banking wallets with zero internet.</a:t>
             </a:r>
           </a:p>
         </p:txBody>
@@ -5792,14 +7573,14 @@
           <a:lstStyle/>
           <a:p>
             <a:pPr>
-              <a:defRPr sz="2400" b="1">
+              <a:defRPr sz="2300" b="1">
                 <a:solidFill>
                   <a:srgbClr val="FFFFFF"/>
                 </a:solidFill>
               </a:defRPr>
             </a:pPr>
             <a:r>
-              <a:t>The Exponential Trajectory: The Next Decade of Local Compute</a:t>
+              <a:t>Precision Agriculture: Autonomous Farm-to-Fork Value Chains</a:t>
             </a:r>
           </a:p>
         </p:txBody>
@@ -5813,7 +7594,7 @@
         <p:spPr>
           <a:xfrm>
             <a:off x="731520" y="1463040"/>
-            <a:ext cx="3328416" cy="4663440"/>
+            <a:ext cx="2468880" cy="4663440"/>
           </a:xfrm>
           <a:prstGeom prst="roundRect">
             <a:avLst/>
@@ -5857,8 +7638,8 @@
         </p:nvSpPr>
         <p:spPr>
           <a:xfrm>
-            <a:off x="914400" y="1645920"/>
-            <a:ext cx="2962656" cy="4297680"/>
+            <a:off x="868680" y="1645920"/>
+            <a:ext cx="2194560" cy="4297680"/>
           </a:xfrm>
           <a:prstGeom prst="rect">
             <a:avLst/>
@@ -5875,35 +7656,26 @@
               <a:spcAft>
                 <a:spcPts val="1200"/>
               </a:spcAft>
-              <a:defRPr sz="1700" b="1">
+              <a:defRPr sz="1500" b="1">
                 <a:solidFill>
                   <a:srgbClr val="00E5FF"/>
                 </a:solidFill>
               </a:defRPr>
             </a:pPr>
             <a:r>
-              <a:t>📶 1. Wi-Fi 8 &amp; mmWave Mesh</a:t>
-            </a:r>
-          </a:p>
-          <a:p>
-            <a:pPr>
-              <a:defRPr sz="1200">
+              <a:t>🌱 Step 1: Fields &amp; Plots</a:t>
+            </a:r>
+          </a:p>
+          <a:p>
+            <a:pPr>
+              <a:defRPr sz="1150">
                 <a:solidFill>
                   <a:srgbClr val="94A3B8"/>
                 </a:solidFill>
               </a:defRPr>
             </a:pPr>
             <a:r>
-              <a:t>Next-gen local wireless will exceed 100 Gbps with sub-millisecond deterministic latency.</a:t>
-            </a:r>
-            <a:br/>
-            <a:br/>
-            <a:r>
-              <a:t>• Entire neighborhood economies will sync databases across peer meshes without relying on cellular towers or ISP uplinks.</a:t>
-            </a:r>
-            <a:br/>
-            <a:r>
-              <a:t>• High-density store-to-store data sharing with zero bandwidth costs.</a:t>
+              <a:t>Geospatial soil mapping, irrigation tracking, and real-time Bulawayo climate sensor integration. Track hectare yields directly on edge devices.</a:t>
             </a:r>
           </a:p>
         </p:txBody>
@@ -5916,8 +7688,8 @@
         </p:nvSpPr>
         <p:spPr>
           <a:xfrm>
-            <a:off x="4425696" y="1463040"/>
-            <a:ext cx="3328416" cy="4663440"/>
+            <a:off x="3429000" y="1463040"/>
+            <a:ext cx="2468880" cy="4663440"/>
           </a:xfrm>
           <a:prstGeom prst="roundRect">
             <a:avLst/>
@@ -5961,8 +7733,8 @@
         </p:nvSpPr>
         <p:spPr>
           <a:xfrm>
-            <a:off x="4608576" y="1645920"/>
-            <a:ext cx="2962656" cy="4297680"/>
+            <a:off x="3566160" y="1645920"/>
+            <a:ext cx="2194560" cy="4297680"/>
           </a:xfrm>
           <a:prstGeom prst="rect">
             <a:avLst/>
@@ -5979,31 +7751,26 @@
               <a:spcAft>
                 <a:spcPts val="1200"/>
               </a:spcAft>
-              <a:defRPr sz="1700" b="1">
+              <a:defRPr sz="1500" b="1">
                 <a:solidFill>
                   <a:srgbClr val="7C4DFF"/>
                 </a:solidFill>
               </a:defRPr>
             </a:pPr>
             <a:r>
-              <a:t>🧠 2. On-Device NPUs &amp; Edge AI</a:t>
-            </a:r>
-          </a:p>
-          <a:p>
-            <a:pPr>
-              <a:defRPr sz="1200">
+              <a:t>🚜 Step 2: Crop Plantings</a:t>
+            </a:r>
+          </a:p>
+          <a:p>
+            <a:pPr>
+              <a:defRPr sz="1150">
                 <a:solidFill>
                   <a:srgbClr val="94A3B8"/>
                 </a:solidFill>
               </a:defRPr>
             </a:pPr>
             <a:r>
-              <a:t>Neural Processing Units (NPUs) on consumer chips will run quantized LLMs locally at 100+ tokens/sec.</a:t>
-            </a:r>
-            <a:br/>
-            <a:br/>
-            <a:r>
-              <a:t>• MADN nodes will execute autonomous inventory forecasting, predictive crop yield analysis, and automated market negotiation right on the farm or cash register.</a:t>
+              <a:t>Structured lifecycle plans from germination to harvest. Fertilizer, labor, and fuel input ledgering linked to field plots.</a:t>
             </a:r>
           </a:p>
         </p:txBody>
@@ -6016,8 +7783,8 @@
         </p:nvSpPr>
         <p:spPr>
           <a:xfrm>
-            <a:off x="8119872" y="1463040"/>
-            <a:ext cx="3328416" cy="4663440"/>
+            <a:off x="6126480" y="1463040"/>
+            <a:ext cx="2468880" cy="4663440"/>
           </a:xfrm>
           <a:prstGeom prst="roundRect">
             <a:avLst/>
@@ -6061,8 +7828,8 @@
         </p:nvSpPr>
         <p:spPr>
           <a:xfrm>
-            <a:off x="8302752" y="1645920"/>
-            <a:ext cx="2962656" cy="4297680"/>
+            <a:off x="6263640" y="1645920"/>
+            <a:ext cx="2194560" cy="4297680"/>
           </a:xfrm>
           <a:prstGeom prst="rect">
             <a:avLst/>
@@ -6079,35 +7846,121 @@
               <a:spcAft>
                 <a:spcPts val="1200"/>
               </a:spcAft>
-              <a:defRPr sz="1700" b="1">
+              <a:defRPr sz="1500" b="1">
+                <a:solidFill>
+                  <a:srgbClr val="F59E0B"/>
+                </a:solidFill>
+              </a:defRPr>
+            </a:pPr>
+            <a:r>
+              <a:t>📊 Step 3: Cost &amp; Price Calc</a:t>
+            </a:r>
+          </a:p>
+          <a:p>
+            <a:pPr>
+              <a:defRPr sz="1150">
+                <a:solidFill>
+                  <a:srgbClr val="94A3B8"/>
+                </a:solidFill>
+              </a:defRPr>
+            </a:pPr>
+            <a:r>
+              <a:t>Automated unit cost calculation factoring seeds, labor, water, and margin targets. Calculates recommended base selling price automatically.</a:t>
+            </a:r>
+          </a:p>
+        </p:txBody>
+      </p:sp>
+      <p:sp>
+        <p:nvSpPr>
+          <p:cNvPr id="10" name="Rounded Rectangle 9"/>
+          <p:cNvSpPr/>
+          <p:nvPr/>
+        </p:nvSpPr>
+        <p:spPr>
+          <a:xfrm>
+            <a:off x="8823960" y="1463040"/>
+            <a:ext cx="2468880" cy="4663440"/>
+          </a:xfrm>
+          <a:prstGeom prst="roundRect">
+            <a:avLst/>
+          </a:prstGeom>
+          <a:solidFill>
+            <a:srgbClr val="111827"/>
+          </a:solidFill>
+          <a:ln w="19050">
+            <a:solidFill>
+              <a:srgbClr val="1F2937"/>
+            </a:solidFill>
+          </a:ln>
+        </p:spPr>
+        <p:style>
+          <a:lnRef idx="1">
+            <a:schemeClr val="accent1"/>
+          </a:lnRef>
+          <a:fillRef idx="3">
+            <a:schemeClr val="accent1"/>
+          </a:fillRef>
+          <a:effectRef idx="2">
+            <a:schemeClr val="accent1"/>
+          </a:effectRef>
+          <a:fontRef idx="minor">
+            <a:schemeClr val="lt1"/>
+          </a:fontRef>
+        </p:style>
+        <p:txBody>
+          <a:bodyPr rtlCol="0" anchor="ctr"/>
+          <a:lstStyle/>
+          <a:p>
+            <a:pPr algn="ctr"/>
+          </a:p>
+        </p:txBody>
+      </p:sp>
+      <p:sp>
+        <p:nvSpPr>
+          <p:cNvPr id="11" name="TextBox 10"/>
+          <p:cNvSpPr txBox="1"/>
+          <p:nvPr/>
+        </p:nvSpPr>
+        <p:spPr>
+          <a:xfrm>
+            <a:off x="8961120" y="1645920"/>
+            <a:ext cx="2194560" cy="4297680"/>
+          </a:xfrm>
+          <a:prstGeom prst="rect">
+            <a:avLst/>
+          </a:prstGeom>
+          <a:noFill/>
+        </p:spPr>
+        <p:txBody>
+          <a:bodyPr wrap="square">
+            <a:spAutoFit/>
+          </a:bodyPr>
+          <a:lstStyle/>
+          <a:p>
+            <a:pPr>
+              <a:spcAft>
+                <a:spcPts val="1200"/>
+              </a:spcAft>
+              <a:defRPr sz="1500" b="1">
                 <a:solidFill>
                   <a:srgbClr val="10B981"/>
                 </a:solidFill>
               </a:defRPr>
             </a:pPr>
             <a:r>
-              <a:t>🌍 3. Sovereign Resilient Economies</a:t>
-            </a:r>
-          </a:p>
-          <a:p>
-            <a:pPr>
-              <a:defRPr sz="1200">
+              <a:t>🏪 Step 4: Harvest POS Sync</a:t>
+            </a:r>
+          </a:p>
+          <a:p>
+            <a:pPr>
+              <a:defRPr sz="1150">
                 <a:solidFill>
                   <a:srgbClr val="94A3B8"/>
                 </a:solidFill>
               </a:defRPr>
             </a:pPr>
             <a:r>
-              <a:t>Decentralization shifts from a theoretical ideal to an undeniable economic advantage.</a:t>
-            </a:r>
-            <a:br/>
-            <a:br/>
-            <a:r>
-              <a:t>• Communities become immune to hyperinflation, platform de-platforming, and subsea cable cuts.</a:t>
-            </a:r>
-            <a:br/>
-            <a:r>
-              <a:t>• Local trade continues seamlessly, privately, and reliably forever.</a:t>
+              <a:t>Harvested crops instantly populate store inventory catalogs. Automated dynamic SKU generation, live stock decrementing, and revenue routing.</a:t>
             </a:r>
           </a:p>
         </p:txBody>
@@ -6196,14 +8049,14 @@
           <a:lstStyle/>
           <a:p>
             <a:pPr>
-              <a:defRPr sz="2400" b="1">
+              <a:defRPr sz="2300" b="1">
                 <a:solidFill>
                   <a:srgbClr val="FFFFFF"/>
                 </a:solidFill>
               </a:defRPr>
             </a:pPr>
             <a:r>
-              <a:t>Conclusion: The Future of Value Systems is Local and Sovereign</a:t>
+              <a:t>Military-Grade Security &amp; Sovereign Zero-Data Exposure</a:t>
             </a:r>
           </a:p>
         </p:txBody>
@@ -6216,8 +8069,8 @@
         </p:nvSpPr>
         <p:spPr>
           <a:xfrm>
-            <a:off x="1097280" y="1371600"/>
-            <a:ext cx="9997135" cy="4846320"/>
+            <a:off x="731520" y="1463040"/>
+            <a:ext cx="5120640" cy="4754880"/>
           </a:xfrm>
           <a:prstGeom prst="roundRect">
             <a:avLst/>
@@ -6227,7 +8080,7 @@
           </a:solidFill>
           <a:ln w="19050">
             <a:solidFill>
-              <a:srgbClr val="00E5FF"/>
+              <a:srgbClr val="10B981"/>
             </a:solidFill>
           </a:ln>
         </p:spPr>
@@ -6261,8 +8114,8 @@
         </p:nvSpPr>
         <p:spPr>
           <a:xfrm>
-            <a:off x="1463040" y="1645920"/>
-            <a:ext cx="9265615" cy="4297680"/>
+            <a:off x="1005840" y="1645920"/>
+            <a:ext cx="4572000" cy="4297680"/>
           </a:xfrm>
           <a:prstGeom prst="rect">
             <a:avLst/>
@@ -6277,143 +8130,153 @@
           <a:p>
             <a:pPr>
               <a:spcAft>
-                <a:spcPts val="1400"/>
+                <a:spcPts val="1000"/>
               </a:spcAft>
-              <a:defRPr sz="2000" b="1">
-                <a:solidFill>
-                  <a:srgbClr val="00E5FF"/>
-                </a:solidFill>
-              </a:defRPr>
-            </a:pPr>
-            <a:r>
-              <a:t>🎯 Summary &amp; Technical Milestones</a:t>
-            </a:r>
-          </a:p>
+              <a:defRPr sz="1700" b="1">
+                <a:solidFill>
+                  <a:srgbClr val="10B981"/>
+                </a:solidFill>
+              </a:defRPr>
+            </a:pPr>
+            <a:r>
+              <a:t>🛡️ Cryptographic Primitives &amp; RAM Keys</a:t>
+            </a:r>
+          </a:p>
+          <a:p>
+            <a:pPr>
+              <a:defRPr sz="1200">
+                <a:solidFill>
+                  <a:srgbClr val="94A3B8"/>
+                </a:solidFill>
+              </a:defRPr>
+            </a:pPr>
+            <a:r>
+              <a:t>Zero hardcoded secrets and memory-isolated key derivation:</a:t>
+            </a:r>
+            <a:br/>
+            <a:br/>
+            <a:r>
+              <a:t>• AES-256-GCM Authenticated Encryption at rest for customer receipts, visitor registries, and KV data.</a:t>
+            </a:r>
+            <a:br/>
+            <a:r>
+              <a:t>• Scrypt Master Key Derivation (N=32768, r=8, p=1) prioritizing dynamic environment passphrases.</a:t>
+            </a:r>
+            <a:br/>
+            <a:r>
+              <a:t>• Tamper-Evident SHA-256 Audit Trails: Chained hash logs where modifying historical entries breaks mathematical verification.</a:t>
+            </a:r>
+            <a:br/>
+            <a:r>
+              <a:t>• Dynamic Tarpit Lockouts: Exponential rate-limiting defeating brute-force credential attacks.</a:t>
+            </a:r>
+          </a:p>
+        </p:txBody>
+      </p:sp>
+      <p:sp>
+        <p:nvSpPr>
+          <p:cNvPr id="6" name="Rounded Rectangle 5"/>
+          <p:cNvSpPr/>
+          <p:nvPr/>
+        </p:nvSpPr>
+        <p:spPr>
+          <a:xfrm>
+            <a:off x="6309360" y="1463040"/>
+            <a:ext cx="5120640" cy="4754880"/>
+          </a:xfrm>
+          <a:prstGeom prst="roundRect">
+            <a:avLst/>
+          </a:prstGeom>
+          <a:solidFill>
+            <a:srgbClr val="111827"/>
+          </a:solidFill>
+          <a:ln w="19050">
+            <a:solidFill>
+              <a:srgbClr val="7C4DFF"/>
+            </a:solidFill>
+          </a:ln>
+        </p:spPr>
+        <p:style>
+          <a:lnRef idx="1">
+            <a:schemeClr val="accent1"/>
+          </a:lnRef>
+          <a:fillRef idx="3">
+            <a:schemeClr val="accent1"/>
+          </a:fillRef>
+          <a:effectRef idx="2">
+            <a:schemeClr val="accent1"/>
+          </a:effectRef>
+          <a:fontRef idx="minor">
+            <a:schemeClr val="lt1"/>
+          </a:fontRef>
+        </p:style>
+        <p:txBody>
+          <a:bodyPr rtlCol="0" anchor="ctr"/>
+          <a:lstStyle/>
+          <a:p>
+            <a:pPr algn="ctr"/>
+          </a:p>
+        </p:txBody>
+      </p:sp>
+      <p:sp>
+        <p:nvSpPr>
+          <p:cNvPr id="7" name="TextBox 6"/>
+          <p:cNvSpPr txBox="1"/>
+          <p:nvPr/>
+        </p:nvSpPr>
+        <p:spPr>
+          <a:xfrm>
+            <a:off x="6583680" y="1645920"/>
+            <a:ext cx="4572000" cy="4297680"/>
+          </a:xfrm>
+          <a:prstGeom prst="rect">
+            <a:avLst/>
+          </a:prstGeom>
+          <a:noFill/>
+        </p:spPr>
+        <p:txBody>
+          <a:bodyPr wrap="square">
+            <a:spAutoFit/>
+          </a:bodyPr>
+          <a:lstStyle/>
           <a:p>
             <a:pPr>
               <a:spcAft>
                 <a:spcPts val="1000"/>
               </a:spcAft>
-              <a:defRPr b="1" sz="1300">
-                <a:solidFill>
-                  <a:srgbClr val="FFFFFF"/>
-                </a:solidFill>
-              </a:defRPr>
-            </a:pPr>
-            <a:r>
-              <a:t>✔ Unlocking Idle Edge Assets: </a:t>
-            </a:r>
-            <a:r>
-              <a:rPr b="0">
+              <a:defRPr sz="1700" b="1">
+                <a:solidFill>
+                  <a:srgbClr val="7C4DFF"/>
+                </a:solidFill>
+              </a:defRPr>
+            </a:pPr>
+            <a:r>
+              <a:t>📦 Self-Replicating Sovereign Nodes</a:t>
+            </a:r>
+          </a:p>
+          <a:p>
+            <a:pPr>
+              <a:defRPr sz="1200">
                 <a:solidFill>
                   <a:srgbClr val="94A3B8"/>
                 </a:solidFill>
-              </a:rPr>
-              <a:t>Transforming commodity consumer devices into zero-cost, high-performance financial infrastructure.</a:t>
-            </a:r>
-          </a:p>
-          <a:p>
-            <a:pPr>
-              <a:spcAft>
-                <a:spcPts val="1000"/>
-              </a:spcAft>
-              <a:defRPr b="1" sz="1300">
-                <a:solidFill>
-                  <a:srgbClr val="FFFFFF"/>
-                </a:solidFill>
-              </a:defRPr>
-            </a:pPr>
-            <a:r>
-              <a:t>✔ 100% Automated Test Matrix: </a:t>
-            </a:r>
-            <a:r>
-              <a:rPr b="0">
-                <a:solidFill>
-                  <a:srgbClr val="94A3B8"/>
-                </a:solidFill>
-              </a:rPr>
-              <a:t>49 comprehensive unit and integration tests passing with 100% reliability across all security and pricing tiers.</a:t>
-            </a:r>
-          </a:p>
-          <a:p>
-            <a:pPr>
-              <a:spcAft>
-                <a:spcPts val="1000"/>
-              </a:spcAft>
-              <a:defRPr b="1" sz="1300">
-                <a:solidFill>
-                  <a:srgbClr val="FFFFFF"/>
-                </a:solidFill>
-              </a:defRPr>
-            </a:pPr>
-            <a:r>
-              <a:t>✔ Multi-Currency &amp; Zero-Coin Vouchers: </a:t>
-            </a:r>
-            <a:r>
-              <a:rPr b="0">
-                <a:solidFill>
-                  <a:srgbClr val="94A3B8"/>
-                </a:solidFill>
-              </a:rPr>
-              <a:t>Native ISO standard ZiG/ZWG, USD, and ZAR settlement with cryptographic offline change vouchers.</a:t>
-            </a:r>
-          </a:p>
-          <a:p>
-            <a:pPr>
-              <a:spcAft>
-                <a:spcPts val="1000"/>
-              </a:spcAft>
-              <a:defRPr b="1" sz="1300">
-                <a:solidFill>
-                  <a:srgbClr val="FFFFFF"/>
-                </a:solidFill>
-              </a:defRPr>
-            </a:pPr>
-            <a:r>
-              <a:t>✔ One-Command Bootstrap: </a:t>
-            </a:r>
-            <a:r>
-              <a:rPr b="0">
-                <a:solidFill>
-                  <a:srgbClr val="94A3B8"/>
-                </a:solidFill>
-              </a:rPr>
-              <a:t>Execute 'python start.py' on any laptop, Raspberry Pi, or server to launch the full autonomous cluster.</a:t>
-            </a:r>
-          </a:p>
-          <a:p>
-            <a:pPr>
-              <a:spcAft>
-                <a:spcPts val="1000"/>
-              </a:spcAft>
-              <a:defRPr b="1" sz="1300">
-                <a:solidFill>
-                  <a:srgbClr val="FFFFFF"/>
-                </a:solidFill>
-              </a:defRPr>
-            </a:pPr>
-            <a:r>
-              <a:t>✔ Next Development Milestone (Cycle 5): </a:t>
-            </a:r>
-            <a:r>
-              <a:rPr b="0">
-                <a:solidFill>
-                  <a:srgbClr val="94A3B8"/>
-                </a:solidFill>
-              </a:rPr>
-              <a:t>Bidirectional P2P vector delta mesh sync and captive Wi-Fi portal access vending on receipts.</a:t>
-            </a:r>
-          </a:p>
-          <a:p>
-            <a:pPr>
-              <a:defRPr sz="1400" b="1">
-                <a:solidFill>
-                  <a:srgbClr val="F59E0B"/>
-                </a:solidFill>
-              </a:defRPr>
-            </a:pPr>
-            <a:r>
-              <a:t>MADN — Sovereign Data • Resilient Trade • Continuous Value</a:t>
+              </a:defRPr>
+            </a:pPr>
+            <a:r>
+              <a:t>Portable node replication and total Git database isolation:</a:t>
+            </a:r>
+            <a:br/>
+            <a:br/>
+            <a:r>
+              <a:t>• Git Database Isolation: All runtime databases (*.db, *.db-wal) are permanently excluded from git sync, guaranteeing zero sensitive customer data exposure on public repositories.</a:t>
+            </a:r>
+            <a:br/>
+            <a:r>
+              <a:t>• Autonomous Node Generator (node_generator.py): Export standalone portable business nodes (e.g. Khumalo Millers, Matopos Dairy) with 1 click.</a:t>
+            </a:r>
+            <a:br/>
+            <a:r>
+              <a:t>• Zero-Config Bootstrapper (start.py): Auto-installs virtual environments, resolves missing dependencies, and spins up local services.</a:t>
             </a:r>
           </a:p>
         </p:txBody>

</xml_diff>

<commit_message>
2026-08-26 Wed 1451: Align Precision Agriculture Slides with Field Plot Infrastructure and Input Cost Ledgering (Ukulungisa 1.19.22)
</commit_message>
<xml_diff>
--- a/01_Documentation_and_Thesis/MADN_Dynamic_Value_Systems_Presentation.pptx
+++ b/01_Documentation_and_Thesis/MADN_Dynamic_Value_Systems_Presentation.pptx
@@ -5634,7 +5634,7 @@
               </a:defRPr>
             </a:pPr>
             <a:r>
-              <a:t>• Geospatial Plot Tracking: </a:t>
+              <a:t>• Field &amp; Plot Provisioning: </a:t>
             </a:r>
             <a:r>
               <a:rPr b="0">
@@ -5642,7 +5642,7 @@
                   <a:srgbClr val="94A3B8"/>
                 </a:solidFill>
               </a:rPr>
-              <a:t>Map farm plots, soil metrics, and Bulawayo micro-climates.</a:t>
+              <a:t>Define physical farm plots, acreage/hectares, soil types, and irrigation infrastructure.</a:t>
             </a:r>
           </a:p>
           <a:p>
@@ -5657,7 +5657,7 @@
               </a:defRPr>
             </a:pPr>
             <a:r>
-              <a:t>• Input Ledgering: </a:t>
+              <a:t>• Input Cost Ledgering: </a:t>
             </a:r>
             <a:r>
               <a:rPr b="0">
@@ -5665,7 +5665,7 @@
                   <a:srgbClr val="94A3B8"/>
                 </a:solidFill>
               </a:rPr>
-              <a:t>Track unit production costs across seeds, fertilizer, and labor.</a:t>
+              <a:t>Track unit production costs across seeds, fertilizer, water, labor, and fuel.</a:t>
             </a:r>
           </a:p>
           <a:p>
@@ -7675,7 +7675,7 @@
               </a:defRPr>
             </a:pPr>
             <a:r>
-              <a:t>Geospatial soil mapping, irrigation tracking, and real-time Bulawayo climate sensor integration. Track hectare yields directly on edge devices.</a:t>
+              <a:t>Provision physical farm plots with acreage/hectare metrics, soil classifications (Loam, Clay, Sand), and irrigation infrastructure setup (Borehole, Drip, Rainfed, Canal).</a:t>
             </a:r>
           </a:p>
         </p:txBody>
@@ -7770,7 +7770,7 @@
               </a:defRPr>
             </a:pPr>
             <a:r>
-              <a:t>Structured lifecycle plans from germination to harvest. Fertilizer, labor, and fuel input ledgering linked to field plots.</a:t>
+              <a:t>Structured lifecycle plans from germination to harvest. Fertilizer, labor, and fuel input ledgering linked directly to field plots.</a:t>
             </a:r>
           </a:p>
         </p:txBody>

</xml_diff>

<commit_message>
2026-08-27 Thu 0850: Instant Profile Settings Visual Feedback and Refocused Local Operator Presentation (Ukusebenza 1.19.23)
</commit_message>
<xml_diff>
--- a/01_Documentation_and_Thesis/MADN_Dynamic_Value_Systems_Presentation.pptx
+++ b/01_Documentation_and_Thesis/MADN_Dynamic_Value_Systems_Presentation.pptx
@@ -3184,7 +3184,7 @@
               </a:defRPr>
             </a:pPr>
             <a:r>
-              <a:t>SOVEREIGN EDGE COMPUTING &amp; DECENTRALIZED VALUATION</a:t>
+              <a:t>LOCAL CONNECTIVITY &amp; OPERATOR DEVELOPMENT FRAMEWORK</a:t>
             </a:r>
           </a:p>
           <a:p>
@@ -3211,26 +3211,26 @@
               <a:spcAft>
                 <a:spcPts val="2800"/>
               </a:spcAft>
-              <a:defRPr sz="1600">
+              <a:defRPr sz="1550">
                 <a:solidFill>
                   <a:srgbClr val="94A3B8"/>
                 </a:solidFill>
               </a:defRPr>
             </a:pPr>
             <a:r>
-              <a:t>Unlocking Exponential Value in Idle Everyday Compute, Multi-Gigabit Local Mesh, and Continuous Algorithmic Pricing</a:t>
-            </a:r>
-          </a:p>
-          <a:p>
-            <a:pPr>
-              <a:defRPr sz="1300" b="1">
+              <a:t>Harnessing High-Speed Local Networking and Idle Edge Hardware to Provide a Composable Framework for Operators to Build Sovereign Economic Systems</a:t>
+            </a:r>
+          </a:p>
+          <a:p>
+            <a:pPr>
+              <a:defRPr sz="1250" b="1">
                 <a:solidFill>
                   <a:srgbClr val="10B981"/>
                 </a:solidFill>
               </a:defRPr>
             </a:pPr>
             <a:r>
-              <a:t>🚀 Zero Cloud Subscriptions • 🔒 AES-256-GCM Vault • ⚡ Wi-Fi 7 Sub-Millisecond Mesh • 🌾 Precision Agri &amp; Touch POS</a:t>
+              <a:t>⚡ Local Wireless Mesh • 🛠️ Composable Operator Framework • 🔒 Zero-Cloud Sovereign Vault • 🌾 Precision Agri &amp; Touch POS</a:t>
             </a:r>
           </a:p>
         </p:txBody>
@@ -3291,7 +3291,7 @@
               </a:defRPr>
             </a:pPr>
             <a:r>
-              <a:t>MODULAR ADAPTIVE DATA NODE (MADN) • DYNAMIC VALUE SYSTEMS</a:t>
+              <a:t>MODULAR ADAPTIVE DATA NODE (MADN) • OPERATOR FRAMEWORK</a:t>
             </a:r>
           </a:p>
         </p:txBody>
@@ -3319,7 +3319,7 @@
           <a:lstStyle/>
           <a:p>
             <a:pPr>
-              <a:defRPr sz="2300" b="1">
+              <a:defRPr sz="2200" b="1">
                 <a:solidFill>
                   <a:srgbClr val="FFFFFF"/>
                 </a:solidFill>
@@ -3695,7 +3695,7 @@
               </a:defRPr>
             </a:pPr>
             <a:r>
-              <a:t>MODULAR ADAPTIVE DATA NODE (MADN) • DYNAMIC VALUE SYSTEMS</a:t>
+              <a:t>MODULAR ADAPTIVE DATA NODE (MADN) • OPERATOR FRAMEWORK</a:t>
             </a:r>
           </a:p>
         </p:txBody>
@@ -3723,14 +3723,14 @@
           <a:lstStyle/>
           <a:p>
             <a:pPr>
-              <a:defRPr sz="2300" b="1">
+              <a:defRPr sz="2200" b="1">
                 <a:solidFill>
                   <a:srgbClr val="FFFFFF"/>
                 </a:solidFill>
               </a:defRPr>
             </a:pPr>
             <a:r>
-              <a:t>Conclusion: The Future of Value Systems is Local and Sovereign</a:t>
+              <a:t>Conclusion: Empowering Operators with Sovereign Systems</a:t>
             </a:r>
           </a:p>
         </p:txBody>
@@ -3828,7 +3828,7 @@
               </a:defRPr>
             </a:pPr>
             <a:r>
-              <a:t>✔ Unlocking Idle Edge Assets: </a:t>
+              <a:t>✔ Local Network Connectivity: </a:t>
             </a:r>
             <a:r>
               <a:rPr b="0">
@@ -3836,7 +3836,7 @@
                   <a:srgbClr val="94A3B8"/>
                 </a:solidFill>
               </a:rPr>
-              <a:t>Transforming commodity consumer devices into zero-cost, high-performance financial infrastructure.</a:t>
+              <a:t>Harnessing multi-gigabit local Wi-Fi and zero-config UDP multicast mesh to eliminate cloud dependency.</a:t>
             </a:r>
           </a:p>
           <a:p>
@@ -3851,7 +3851,7 @@
               </a:defRPr>
             </a:pPr>
             <a:r>
-              <a:t>✔ 100% Automated Test Matrix: </a:t>
+              <a:t>✔ Composable Operator Framework: </a:t>
             </a:r>
             <a:r>
               <a:rPr b="0">
@@ -3859,7 +3859,7 @@
                   <a:srgbClr val="94A3B8"/>
                 </a:solidFill>
               </a:rPr>
-              <a:t>49 comprehensive unit and integration tests passing with 100% reliability across all security and pricing tiers.</a:t>
+              <a:t>Enabling operators to deploy custom business ledgers, touch POS registers, dynamic pricing, and precision agriculture.</a:t>
             </a:r>
           </a:p>
           <a:p>
@@ -3874,7 +3874,7 @@
               </a:defRPr>
             </a:pPr>
             <a:r>
-              <a:t>✔ Multi-Currency &amp; Zero-Coin Vouchers: </a:t>
+              <a:t>✔ 100% Automated Test Matrix: </a:t>
             </a:r>
             <a:r>
               <a:rPr b="0">
@@ -3882,7 +3882,7 @@
                   <a:srgbClr val="94A3B8"/>
                 </a:solidFill>
               </a:rPr>
-              <a:t>Native ISO standard ZiG/ZWG, USD, and ZAR settlement with cryptographic offline change vouchers.</a:t>
+              <a:t>49 comprehensive unit and integration tests passing with 100% reliability across all security and pricing tiers.</a:t>
             </a:r>
           </a:p>
           <a:p>
@@ -3897,7 +3897,7 @@
               </a:defRPr>
             </a:pPr>
             <a:r>
-              <a:t>✔ One-Command Bootstrap: </a:t>
+              <a:t>✔ Multi-Currency &amp; Zero-Coin Vouchers: </a:t>
             </a:r>
             <a:r>
               <a:rPr b="0">
@@ -3905,7 +3905,7 @@
                   <a:srgbClr val="94A3B8"/>
                 </a:solidFill>
               </a:rPr>
-              <a:t>Execute 'python start.py' on any laptop, Raspberry Pi, or server to launch the full autonomous cluster.</a:t>
+              <a:t>Native ISO standard ZiG/ZWG, USD, and ZAR settlement with cryptographic offline change vouchers.</a:t>
             </a:r>
           </a:p>
           <a:p>
@@ -3920,7 +3920,7 @@
               </a:defRPr>
             </a:pPr>
             <a:r>
-              <a:t>✔ Next Development Milestone (Cycle 5): </a:t>
+              <a:t>✔ One-Command Bootstrap: </a:t>
             </a:r>
             <a:r>
               <a:rPr b="0">
@@ -3928,7 +3928,7 @@
                   <a:srgbClr val="94A3B8"/>
                 </a:solidFill>
               </a:rPr>
-              <a:t>Bidirectional P2P vector delta mesh sync and captive Wi-Fi portal access vending on receipts.</a:t>
+              <a:t>Execute 'python start.py' on any laptop, Raspberry Pi, or server to launch the full autonomous cluster.</a:t>
             </a:r>
           </a:p>
           <a:p>
@@ -3940,7 +3940,7 @@
               </a:defRPr>
             </a:pPr>
             <a:r>
-              <a:t>MADN — Sovereign Data • Resilient Trade • Continuous Value</a:t>
+              <a:t>MADN — Local Connectivity • Operator Sovereignty • Continuous Value</a:t>
             </a:r>
           </a:p>
         </p:txBody>
@@ -4001,7 +4001,7 @@
               </a:defRPr>
             </a:pPr>
             <a:r>
-              <a:t>MODULAR ADAPTIVE DATA NODE (MADN) • DYNAMIC VALUE SYSTEMS</a:t>
+              <a:t>MODULAR ADAPTIVE DATA NODE (MADN) • OPERATOR FRAMEWORK</a:t>
             </a:r>
           </a:p>
         </p:txBody>
@@ -4029,14 +4029,14 @@
           <a:lstStyle/>
           <a:p>
             <a:pPr>
-              <a:defRPr sz="2300" b="1">
+              <a:defRPr sz="2200" b="1">
                 <a:solidFill>
                   <a:srgbClr val="FFFFFF"/>
                 </a:solidFill>
               </a:defRPr>
             </a:pPr>
             <a:r>
-              <a:t>The Hardware &amp; Bandwidth Revolution: 1999 vs. Today</a:t>
+              <a:t>The Hardware &amp; Bandwidth Revolution: Why Local Compute Wins</a:t>
             </a:r>
           </a:p>
         </p:txBody>
@@ -4119,7 +4119,7 @@
               </a:defRPr>
             </a:pPr>
             <a:r>
-              <a:t>⏳ 1999: The Centralized Cloud Era Begins</a:t>
+              <a:t>⏳ 1999: Why Clouds Were Mandatory</a:t>
             </a:r>
           </a:p>
           <a:p>
@@ -4165,7 +4165,7 @@
                   <a:srgbClr val="94A3B8"/>
                 </a:solidFill>
               </a:rPr>
-              <a:t>56 kbps Dial-up or 10 Mbps Wired Ethernet. Severely congested copper lines.</a:t>
+              <a:t>56 kbps Dial-up or 10 Mbps Wired Ethernet. Copper lines with high packet congestion.</a:t>
             </a:r>
           </a:p>
           <a:p>
@@ -4188,7 +4188,7 @@
                   <a:srgbClr val="94A3B8"/>
                 </a:solidFill>
               </a:rPr>
-              <a:t>50 ms – 150 ms roundtrips. High packet loss and expensive long-distance routes.</a:t>
+              <a:t>50 ms – 150 ms roundtrips over distant long-haul telecom links.</a:t>
             </a:r>
           </a:p>
           <a:p>
@@ -4211,7 +4211,7 @@
                   <a:srgbClr val="94A3B8"/>
                 </a:solidFill>
               </a:rPr>
-              <a:t>10 GB Spinning IDE HDD @ 5–10 MB/s. Fragile moving magnetic heads.</a:t>
+              <a:t>10 GB Spinning IDE HDD @ 5–10 MB/s. Slow magnetic mechanical heads.</a:t>
             </a:r>
           </a:p>
           <a:p>
@@ -4226,7 +4226,7 @@
               </a:defRPr>
             </a:pPr>
             <a:r>
-              <a:t>• Architectural Result: </a:t>
+              <a:t>• The Legacy Result: </a:t>
             </a:r>
             <a:r>
               <a:rPr b="0">
@@ -4234,7 +4234,7 @@
                   <a:srgbClr val="94A3B8"/>
                 </a:solidFill>
               </a:rPr>
-              <a:t>Centralized server farms were mandatory because client devices were too weak to compute.</a:t>
+              <a:t>Centralized server farms were necessary because client devices were too weak to run systems.</a:t>
             </a:r>
           </a:p>
         </p:txBody>
@@ -4317,7 +4317,7 @@
               </a:defRPr>
             </a:pPr>
             <a:r>
-              <a:t>⚡ Today: Ubiquitous Edge Supercomputing</a:t>
+              <a:t>⚡ Today: Local Network Supercomputing</a:t>
             </a:r>
           </a:p>
           <a:p>
@@ -4340,7 +4340,7 @@
                   <a:srgbClr val="94A3B8"/>
                 </a:solidFill>
               </a:rPr>
-              <a:t>16 GB – 32 GB LPDDR5X (500x capacity, 100x speed) in pocket phones and mini-PCs.</a:t>
+              <a:t>16 GB – 32 GB LPDDR5X (500x capacity, 100x speed) in consumer laptops and edge nodes.</a:t>
             </a:r>
           </a:p>
           <a:p>
@@ -4355,7 +4355,7 @@
               </a:defRPr>
             </a:pPr>
             <a:r>
-              <a:t>• Network Bandwidth: </a:t>
+              <a:t>• Local Bandwidth: </a:t>
             </a:r>
             <a:r>
               <a:rPr b="0">
@@ -4363,7 +4363,7 @@
                   <a:srgbClr val="94A3B8"/>
                 </a:solidFill>
               </a:rPr>
-              <a:t>Wi-Fi 7 (802.11be) delivering 5,000 – 30,000 Mbps over the air. Zero cables needed.</a:t>
+              <a:t>Wi-Fi 7 (802.11be) delivering 5,000 – 30,000 Mbps over local airwaves without cables.</a:t>
             </a:r>
           </a:p>
           <a:p>
@@ -4378,7 +4378,7 @@
               </a:defRPr>
             </a:pPr>
             <a:r>
-              <a:t>• Network Latency: </a:t>
+              <a:t>• Local Latency: </a:t>
             </a:r>
             <a:r>
               <a:rPr b="0">
@@ -4386,7 +4386,7 @@
                   <a:srgbClr val="94A3B8"/>
                 </a:solidFill>
               </a:rPr>
-              <a:t>Sub-2 ms local mesh roundtrips. 50x lower latency than remote cloud servers.</a:t>
+              <a:t>Sub-2 ms local wireless mesh roundtrips. 50x faster than routing to cloud servers.</a:t>
             </a:r>
           </a:p>
           <a:p>
@@ -4424,7 +4424,7 @@
               </a:defRPr>
             </a:pPr>
             <a:r>
-              <a:t>• The Opportunity: </a:t>
+              <a:t>• Operator Opportunity: </a:t>
             </a:r>
             <a:r>
               <a:rPr b="0">
@@ -4432,7 +4432,7 @@
                   <a:srgbClr val="94A3B8"/>
                 </a:solidFill>
               </a:rPr>
-              <a:t>Consumer edge devices now outgun 1999 datacenters by orders of magnitude!</a:t>
+              <a:t>Operators can now build full-fledged, high-throughput autonomous systems on local hardware!</a:t>
             </a:r>
           </a:p>
         </p:txBody>
@@ -4493,7 +4493,7 @@
               </a:defRPr>
             </a:pPr>
             <a:r>
-              <a:t>MODULAR ADAPTIVE DATA NODE (MADN) • DYNAMIC VALUE SYSTEMS</a:t>
+              <a:t>MODULAR ADAPTIVE DATA NODE (MADN) • OPERATOR FRAMEWORK</a:t>
             </a:r>
           </a:p>
         </p:txBody>
@@ -4521,7 +4521,7 @@
           <a:lstStyle/>
           <a:p>
             <a:pPr>
-              <a:defRPr sz="2300" b="1">
+              <a:defRPr sz="2200" b="1">
                 <a:solidFill>
                   <a:srgbClr val="FFFFFF"/>
                 </a:solidFill>
@@ -4657,7 +4657,7 @@
                   <a:srgbClr val="94A3B8"/>
                 </a:solidFill>
               </a:rPr>
-              <a:t>Local micro-transactions travel thousands of kilometers across global backbones, incurring high egress tolls and unacceptable network delays.</a:t>
+              <a:t>Local micro-transactions travel thousands of kilometers across global backbones, incurring high egress tolls and network delays.</a:t>
             </a:r>
           </a:p>
         </p:txBody>
@@ -4786,7 +4786,7 @@
                   <a:srgbClr val="94A3B8"/>
                 </a:solidFill>
               </a:rPr>
-              <a:t>Shoppers are forced into arbitrary unwanted purchases (sweets, matches) or loose change forfeit, eroding purchasing power and merchant trust.</a:t>
+              <a:t>Shoppers are forced into arbitrary unwanted purchases or loose change forfeit, eroding purchasing power and merchant trust.</a:t>
             </a:r>
           </a:p>
         </p:txBody>
@@ -4892,7 +4892,7 @@
                   <a:srgbClr val="94A3B8"/>
                 </a:solidFill>
               </a:rPr>
-              <a:t>Fresh agricultural produce (tomatoes, dairy, leafy greens) depreciates rapidly, but conventional static POS systems fail to adjust prices dynamically.</a:t>
+              <a:t>Fresh agricultural produce depreciates rapidly, but conventional static POS systems fail to adjust prices dynamically.</a:t>
             </a:r>
           </a:p>
           <a:p>
@@ -5021,7 +5021,7 @@
                   <a:srgbClr val="94A3B8"/>
                 </a:solidFill>
               </a:rPr>
-              <a:t>Small businesses and agricultural communities surrender sensitive financial logs and operational telemetry to foreign SaaS platforms.</a:t>
+              <a:t>Small businesses and agricultural operators surrender sensitive financial logs and operational telemetry to foreign SaaS platforms.</a:t>
             </a:r>
           </a:p>
           <a:p>
@@ -5105,7 +5105,7 @@
               </a:defRPr>
             </a:pPr>
             <a:r>
-              <a:t>MODULAR ADAPTIVE DATA NODE (MADN) • DYNAMIC VALUE SYSTEMS</a:t>
+              <a:t>MODULAR ADAPTIVE DATA NODE (MADN) • OPERATOR FRAMEWORK</a:t>
             </a:r>
           </a:p>
         </p:txBody>
@@ -5133,14 +5133,14 @@
           <a:lstStyle/>
           <a:p>
             <a:pPr>
-              <a:defRPr sz="2300" b="1">
+              <a:defRPr sz="2200" b="1">
                 <a:solidFill>
                   <a:srgbClr val="FFFFFF"/>
                 </a:solidFill>
               </a:defRPr>
             </a:pPr>
             <a:r>
-              <a:t>Research Objectives: Engineering Sovereign Edge Valuation</a:t>
+              <a:t>Research Objectives: Building the Sovereign Operator Framework</a:t>
             </a:r>
           </a:p>
         </p:txBody>
@@ -5232,7 +5232,7 @@
               </a:defRPr>
             </a:pPr>
             <a:r>
-              <a:t>To architect, develop, and empirically validate an offline-first Modular Adaptive Data Node (MADN) ecosystem that leverages idle commodity edge hardware and local high-bandwidth wireless mesh to enable autonomous, tamper-evident dynamic valuation, multi-tender settlement, and closed-loop agro-industrial tracking.</a:t>
+              <a:t>To architect, develop, and empirically validate an offline-first Modular Adaptive Data Node (MADN) framework that leverages local network connectivity and idle edge hardware, empowering operators to deploy sovereign dynamic pricing, multi-tender settlement, and agro-industrial systems.</a:t>
             </a:r>
           </a:p>
         </p:txBody>
@@ -5315,7 +5315,7 @@
               </a:defRPr>
             </a:pPr>
             <a:r>
-              <a:t>RO-1: Tri-Node Edge Mesh Architecture</a:t>
+              <a:t>RO-1: Local Mesh &amp; Tri-Node Architecture</a:t>
             </a:r>
           </a:p>
           <a:p>
@@ -5353,7 +5353,7 @@
               </a:defRPr>
             </a:pPr>
             <a:r>
-              <a:t>• Multicast Mesh: </a:t>
+              <a:t>• Multicast Discovery: </a:t>
             </a:r>
             <a:r>
               <a:rPr b="0">
@@ -5361,7 +5361,7 @@
                   <a:srgbClr val="94A3B8"/>
                 </a:solidFill>
               </a:rPr>
-              <a:t>Implement zero-config UDP multicast peer discovery (224.0.0.251:8001).</a:t>
+              <a:t>Implement zero-config UDP multicast peer discovery (224.0.0.251:8001) over local Wi-Fi.</a:t>
             </a:r>
           </a:p>
           <a:p>
@@ -5467,7 +5467,7 @@
               </a:defRPr>
             </a:pPr>
             <a:r>
-              <a:t>RO-2: Dynamic Value &amp; Pricing Engine</a:t>
+              <a:t>RO-2: Dynamic Value &amp; Multi-Tender Engine</a:t>
             </a:r>
           </a:p>
           <a:p>
@@ -5771,7 +5771,7 @@
               </a:defRPr>
             </a:pPr>
             <a:r>
-              <a:t>RO-4: Zero-Exposure Security &amp; Portability</a:t>
+              <a:t>RO-4: Sovereign Security &amp; Node Portability</a:t>
             </a:r>
           </a:p>
           <a:p>
@@ -5840,7 +5840,7 @@
                   <a:srgbClr val="94A3B8"/>
                 </a:solidFill>
               </a:rPr>
-              <a:t>Implement one-click portable node generation (node_generator.py) with zero database exposure.</a:t>
+              <a:t>Implement one-click portable node generation (node_generator.py) for instant edge deployment.</a:t>
             </a:r>
           </a:p>
         </p:txBody>
@@ -5901,7 +5901,7 @@
               </a:defRPr>
             </a:pPr>
             <a:r>
-              <a:t>MODULAR ADAPTIVE DATA NODE (MADN) • DYNAMIC VALUE SYSTEMS</a:t>
+              <a:t>MODULAR ADAPTIVE DATA NODE (MADN) • OPERATOR FRAMEWORK</a:t>
             </a:r>
           </a:p>
         </p:txBody>
@@ -5929,7 +5929,7 @@
           <a:lstStyle/>
           <a:p>
             <a:pPr>
-              <a:defRPr sz="2300" b="1">
+              <a:defRPr sz="2200" b="1">
                 <a:solidFill>
                   <a:srgbClr val="FFFFFF"/>
                 </a:solidFill>
@@ -6036,7 +6036,7 @@
             <a:br/>
             <a:br/>
             <a:r>
-              <a:t>• Dynamic real-time touch POS register.</a:t>
+              <a:t>• Touch POS Register with instant catalog search and multi-currency checkout.</a:t>
             </a:r>
             <a:br/>
             <a:r>
@@ -6044,7 +6044,7 @@
             </a:r>
             <a:br/>
             <a:r>
-              <a:t>• Condition-gated progressive disclosure (Store Setup -&gt; POS -&gt; Marketplace).</a:t>
+              <a:t>• Precondition-gated progressive disclosure (Store Setup -&gt; POS -&gt; Marketplace).</a:t>
             </a:r>
             <a:br/>
             <a:r>
@@ -6333,7 +6333,7 @@
               </a:defRPr>
             </a:pPr>
             <a:r>
-              <a:t>MODULAR ADAPTIVE DATA NODE (MADN) • DYNAMIC VALUE SYSTEMS</a:t>
+              <a:t>MODULAR ADAPTIVE DATA NODE (MADN) • OPERATOR FRAMEWORK</a:t>
             </a:r>
           </a:p>
         </p:txBody>
@@ -6361,7 +6361,7 @@
           <a:lstStyle/>
           <a:p>
             <a:pPr>
-              <a:defRPr sz="2300" b="1">
+              <a:defRPr sz="2200" b="1">
                 <a:solidFill>
                   <a:srgbClr val="FFFFFF"/>
                 </a:solidFill>
@@ -7146,7 +7146,7 @@
               </a:defRPr>
             </a:pPr>
             <a:r>
-              <a:t>🔗 INTER-NODE PROTOCOLS &amp; DATA PIPELINES</a:t>
+              <a:t>🔗 LOCAL NETWORK PROTOCOLS &amp; DATA PIPELINES</a:t>
             </a:r>
           </a:p>
           <a:p>
@@ -7158,7 +7158,7 @@
               </a:defRPr>
             </a:pPr>
             <a:r>
-              <a:t>① Operator ↔ Vault: JSON REST + HMAC-SHA256 Bearer &amp; HttpOnly Session Cookies  |  ② Vault ↔ Data Node: HTTP Collection Sync &amp; Collision Validation  |  ③ Data Node ↔ Mesh: UDP Multicast (224.0.0.251:8001) Zero-Config Beacon  |  ④ Vault ↔ Edge Device: Scrypt Derived AES-256-GCM Storage</a:t>
+              <a:t>① Operator ↔ Vault: Local JSON REST + HMAC Bearer &amp; HttpOnly Cookies  |  ② Vault ↔ Data Node: HTTP Collection Sync &amp; Collision Validation  |  ③ Data Node ↔ Local Mesh: UDP Multicast (224.0.0.251:8001) Zero-Config Beacon  |  ④ Vault ↔ Edge Device: Scrypt Derived AES-256-GCM Storage</a:t>
             </a:r>
           </a:p>
         </p:txBody>
@@ -7219,7 +7219,7 @@
               </a:defRPr>
             </a:pPr>
             <a:r>
-              <a:t>MODULAR ADAPTIVE DATA NODE (MADN) • DYNAMIC VALUE SYSTEMS</a:t>
+              <a:t>MODULAR ADAPTIVE DATA NODE (MADN) • OPERATOR FRAMEWORK</a:t>
             </a:r>
           </a:p>
         </p:txBody>
@@ -7247,14 +7247,14 @@
           <a:lstStyle/>
           <a:p>
             <a:pPr>
-              <a:defRPr sz="2300" b="1">
+              <a:defRPr sz="2200" b="1">
                 <a:solidFill>
                   <a:srgbClr val="FFFFFF"/>
                 </a:solidFill>
               </a:defRPr>
             </a:pPr>
             <a:r>
-              <a:t>Dynamic Value Systems: Continuous Pricing &amp; Multi-Tender Settlement</a:t>
+              <a:t>Dynamic Value Systems: Algorithmic Pricing &amp; Multi-Tender Settlement</a:t>
             </a:r>
           </a:p>
         </p:txBody>
@@ -7476,7 +7476,7 @@
             <a:br/>
             <a:br/>
             <a:r>
-              <a:t>• Solves Change Shortages: Mint cryptographic QR change vouchers when physical coins are unavailable.</a:t>
+              <a:t>• Solves Coin Shortages: Mint cryptographic QR change vouchers when physical coins are unavailable.</a:t>
             </a:r>
             <a:br/>
             <a:r>
@@ -7545,7 +7545,7 @@
               </a:defRPr>
             </a:pPr>
             <a:r>
-              <a:t>MODULAR ADAPTIVE DATA NODE (MADN) • DYNAMIC VALUE SYSTEMS</a:t>
+              <a:t>MODULAR ADAPTIVE DATA NODE (MADN) • OPERATOR FRAMEWORK</a:t>
             </a:r>
           </a:p>
         </p:txBody>
@@ -7573,7 +7573,7 @@
           <a:lstStyle/>
           <a:p>
             <a:pPr>
-              <a:defRPr sz="2300" b="1">
+              <a:defRPr sz="2200" b="1">
                 <a:solidFill>
                   <a:srgbClr val="FFFFFF"/>
                 </a:solidFill>
@@ -8021,7 +8021,7 @@
               </a:defRPr>
             </a:pPr>
             <a:r>
-              <a:t>MODULAR ADAPTIVE DATA NODE (MADN) • DYNAMIC VALUE SYSTEMS</a:t>
+              <a:t>MODULAR ADAPTIVE DATA NODE (MADN) • OPERATOR FRAMEWORK</a:t>
             </a:r>
           </a:p>
         </p:txBody>
@@ -8049,7 +8049,7 @@
           <a:lstStyle/>
           <a:p>
             <a:pPr>
-              <a:defRPr sz="2300" b="1">
+              <a:defRPr sz="2200" b="1">
                 <a:solidFill>
                   <a:srgbClr val="FFFFFF"/>
                 </a:solidFill>

</xml_diff>